<commit_message>
1029 deck: one slide, bidirectional ring attention (dense or sparse) is not comm-bound; causal KV-cache workload needed
Measured numbers bold, projected numbers blue.

Co-Authored-By: Claude Opus 5.5 <noreply@anthropic.com>
</commit_message>
<xml_diff>
--- a/meetings/Mingjia-1029-update.pptx
+++ b/meetings/Mingjia-1029-update.pptx
@@ -9,7 +9,6 @@
   </p:notesMasterIdLst>
   <p:sldIdLst>
     <p:sldId id="256" r:id="rId7"/>
-    <p:sldId id="257" r:id="rId12"/>
   </p:sldIdLst>
   <p:sldSz cy="5143500" cx="9144000"/>
   <p:notesSz cx="6858000" cy="9144000"/>
@@ -772,65 +771,7 @@
           <a:lstStyle/>
           <a:p>
             <a:r>
-              <a:t>Source: docs/ring_attn_overhead.md (sections 2, 3.2, 5). One attention layer, Wan2.1-14B shapes (40 heads x 128), ring-flash-attn 0.1.8; overhead = distributed time / single-kernel flash-attention time - 1. 2-node rows: lowprio 2 x 4 H200; 4-channel rows average two node pairs.</a:t>
-            </a:r>
-          </a:p>
-        </p:txBody>
-      </p:sp>
-    </p:spTree>
-  </p:cSld>
-  <p:clrMapOvr>
-    <a:masterClrMapping/>
-  </p:clrMapOvr>
-</p:notes>
-</file>
-
-<file path=ppt/notesSlides/notesSlide2.xml><?xml version="1.0" encoding="utf-8"?>
-<p:notes xmlns:a="http://schemas.openxmlformats.org/drawingml/2006/main" xmlns:p="http://schemas.openxmlformats.org/presentationml/2006/main" xmlns:r="http://schemas.openxmlformats.org/officeDocument/2006/relationships">
-  <p:cSld>
-    <p:spTree>
-      <p:nvGrpSpPr>
-        <p:cNvPr id="1" name=""/>
-        <p:cNvGrpSpPr/>
-        <p:nvPr/>
-      </p:nvGrpSpPr>
-      <p:grpSpPr>
-        <a:xfrm>
-          <a:off x="0" y="0"/>
-          <a:ext cx="0" cy="0"/>
-          <a:chOff x="0" y="0"/>
-          <a:chExt cx="0" cy="0"/>
-        </a:xfrm>
-      </p:grpSpPr>
-      <p:sp>
-        <p:nvSpPr>
-          <p:cNvPr id="2" name="Slide Image Placeholder 1"/>
-          <p:cNvSpPr>
-            <a:spLocks noGrp="1"/>
-          </p:cNvSpPr>
-          <p:nvPr>
-            <p:ph type="sldImg" idx="2"/>
-          </p:nvPr>
-        </p:nvSpPr>
-        <p:spPr/>
-      </p:sp>
-      <p:sp>
-        <p:nvSpPr>
-          <p:cNvPr id="3" name="Notes Placeholder 2"/>
-          <p:cNvSpPr>
-            <a:spLocks noGrp="1"/>
-          </p:cNvSpPr>
-          <p:nvPr>
-            <p:ph type="body" idx="1"/>
-          </p:nvPr>
-        </p:nvSpPr>
-        <p:spPr/>
-        <p:txBody>
-          <a:bodyPr/>
-          <a:lstStyle/>
-          <a:p>
-            <a:r>
-              <a:t>Source: docs/ring_attn_overhead.md section 4 and model_ring.py. Exposed comm fitted as max(beta x, x - eta) + phi on all measurements; NVL72 / glass use the NVLink pair-curve shape scaled to peak, H200 compute. Sparse = compute x 0.135, KV traffic unchanged.</a:t>
+              <a:t>Source: docs/ring_attn_overhead.md and model_ring.py. Overhead = distributed attention time / single-kernel flash-attention time - 1, training step (fwd+bwd), Wan2.1-14B shapes (40 heads x 128), H200 compute. 5 s = 680K tokens, 10 s = 1.33M tokens. Measured row: 2 nodes x 4 H200, NCCL_NCHANNELS_PER_NET_PEER=4 (NCCL default gets 20 GB/s and roughly doubles cross-node ring overhead). Projections: model fitted to all measurements (median error &lt; 4%); NVL72 0.9 TB/s, glass 4 TB/s per GPU. Sparse = compute x 0.135 (PAN trace), KV traffic unchanged. All rows are full-sequence passes (diffusion / training step), not KV-cache decode. Ulysses degree must divide 40 heads, so at most 8 inside a node; more GPUs need Ulysses x ring.</a:t>
             </a:r>
           </a:p>
         </p:txBody>
@@ -9049,7 +8990,7 @@
         <p:spPr>
           <a:xfrm>
             <a:off x="311700" y="955000"/>
-            <a:ext cx="8520600" cy="1325880"/>
+            <a:ext cx="8520600" cy="1463040"/>
           </a:xfrm>
           <a:prstGeom prst="rect">
             <a:avLst/>
@@ -9080,7 +9021,7 @@
                   <a:schemeClr val="dk1"/>
                 </a:solidFill>
               </a:rPr>
-              <a:t>Glass ML + ring attention overhead (training and inference)</a:t>
+              <a:t>Ring attention: bidirectional video is not comm-bound, even with sparse attention</a:t>
             </a:r>
             <a:endParaRPr sz="1200">
               <a:solidFill>
@@ -9108,7 +9049,7 @@
                   <a:schemeClr val="dk1"/>
                 </a:solidFill>
               </a:rPr>
-              <a:t>Why ring</a:t>
+              <a:t>Why</a:t>
             </a:r>
             <a:r>
               <a:rPr lang="en" sz="1200">
@@ -9116,7 +9057,7 @@
                   <a:schemeClr val="dk1"/>
                 </a:solidFill>
               </a:rPr>
-              <a:t>: 4K video outgrows Ulysses; Wan2.1-14B has 40 heads, so Ulysses stops at 8 GPUs</a:t>
+              <a:t>: per ring step compute grows as s², KV traffic as s (s = tokens/GPU); 4K video: s ≥ 80K</a:t>
             </a:r>
             <a:endParaRPr sz="1200">
               <a:solidFill>
@@ -9144,7 +9085,7 @@
                   <a:schemeClr val="dk1"/>
                 </a:solidFill>
               </a:rPr>
-              <a:t>Setting</a:t>
+              <a:t>Dense</a:t>
             </a:r>
             <a:r>
               <a:rPr lang="en" sz="1200">
@@ -9152,7 +9093,7 @@
                   <a:schemeClr val="dk1"/>
                 </a:solidFill>
               </a:rPr>
-              <a:t>: one attention layer, 4K 5 s = 680K tokens; 8x H200, NVLink vs 2 nodes x 4 over IB</a:t>
+              <a:t>: Ulysses in node x ring across nodes hides comm on IB (1% measured); glass adds nothing</a:t>
             </a:r>
             <a:endParaRPr sz="1200">
               <a:solidFill>
@@ -9180,7 +9121,7 @@
                   <a:schemeClr val="dk1"/>
                 </a:solidFill>
               </a:rPr>
-              <a:t>Tokens per GPU (s) decide overhead</a:t>
+              <a:t>+ Sparse</a:t>
             </a:r>
             <a:r>
               <a:rPr lang="en" sz="1200">
@@ -9188,7 +9129,7 @@
                   <a:schemeClr val="dk1"/>
                 </a:solidFill>
               </a:rPr>
-              <a:t>: per ring step compute grows as s², KV traffic as s</a:t>
+              <a:t> (13.5% compute, same KV bytes): still 5% at 16 GPUs; shows only at 64 GPUs/sample</a:t>
             </a:r>
             <a:endParaRPr sz="1200">
               <a:solidFill>
@@ -9216,7 +9157,7 @@
                   <a:schemeClr val="dk1"/>
                 </a:solidFill>
               </a:rPr>
-              <a:t>NCCL default uses 40% of IB</a:t>
+              <a:t>Need a causal workload</a:t>
             </a:r>
             <a:r>
               <a:rPr lang="en" sz="1200">
@@ -9224,7 +9165,7 @@
                   <a:schemeClr val="dk1"/>
                 </a:solidFill>
               </a:rPr>
-              <a:t>: 2 channels per peer = 20 of 50 GB/s; 4 channels: 26-34 GB/s</a:t>
+              <a:t>: chunk-by-chunk generation, full-history KV cache, sparse selection</a:t>
             </a:r>
             <a:endParaRPr sz="1200">
               <a:solidFill>
@@ -9241,8 +9182,8 @@
           <p:nvPr/>
         </p:nvGraphicFramePr>
         <p:xfrm>
-          <a:off x="411480" y="2514600"/>
-          <a:ext cx="4937760" cy="1571250"/>
+          <a:off x="411480" y="2487168"/>
+          <a:ext cx="5440680" cy="1947672"/>
         </p:xfrm>
         <a:graphic>
           <a:graphicData uri="http://schemas.openxmlformats.org/drawingml/2006/table">
@@ -9252,11 +9193,13 @@
                 <a:tableStyleId>{560E7119-B5C1-419B-856C-2FA07D2E47C7}</a:tableStyleId>
               </a:tblPr>
               <a:tblGrid>
-                <a:gridCol w="2377440"/>
-                <a:gridCol w="1280160"/>
-                <a:gridCol w="1280160"/>
+                <a:gridCol w="2743200"/>
+                <a:gridCol w="457200"/>
+                <a:gridCol w="777240"/>
+                <a:gridCol w="731520"/>
+                <a:gridCol w="731520"/>
               </a:tblGrid>
-              <a:tr h="314250">
+              <a:tr h="411480">
                 <a:tc>
                   <a:txBody>
                     <a:bodyPr/>
@@ -9273,7 +9216,7 @@
                       </a:pPr>
                       <a:r>
                         <a:rPr lang="en" sz="1000"/>
-                        <a:t>Overhead (inference / training)</a:t>
+                        <a:t>Training overhead (bold: measured, blue: projected)</a:t>
                       </a:r>
                       <a:endParaRPr sz="1000"/>
                     </a:p>
@@ -9333,7 +9276,7 @@
                       </a:pPr>
                       <a:r>
                         <a:rPr lang="en" sz="1000"/>
-                        <a:t>16K tokens/GPU</a:t>
+                        <a:t>GPUs</a:t>
                       </a:r>
                       <a:endParaRPr sz="1000"/>
                     </a:p>
@@ -9393,69 +9336,7 @@
                       </a:pPr>
                       <a:r>
                         <a:rPr lang="en" sz="1000"/>
-                        <a:t>85K tokens/GPU</a:t>
-                      </a:r>
-                      <a:endParaRPr sz="1000"/>
-                    </a:p>
-                  </a:txBody>
-                  <a:tcPr marT="91425" marB="91425" marR="91425" marL="91425">
-                    <a:lnL cap="flat" cmpd="sng" w="9525">
-                      <a:solidFill>
-                        <a:schemeClr val="dk1"/>
-                      </a:solidFill>
-                      <a:prstDash val="solid"/>
-                      <a:round/>
-                      <a:headEnd len="sm" w="sm" type="none"/>
-                      <a:tailEnd len="sm" w="sm" type="none"/>
-                    </a:lnL>
-                    <a:lnR cap="flat" cmpd="sng" w="9525">
-                      <a:solidFill>
-                        <a:schemeClr val="dk1"/>
-                      </a:solidFill>
-                      <a:prstDash val="solid"/>
-                      <a:round/>
-                      <a:headEnd len="sm" w="sm" type="none"/>
-                      <a:tailEnd len="sm" w="sm" type="none"/>
-                    </a:lnR>
-                    <a:lnT cap="flat" cmpd="sng" w="9525">
-                      <a:solidFill>
-                        <a:schemeClr val="dk1"/>
-                      </a:solidFill>
-                      <a:prstDash val="solid"/>
-                      <a:round/>
-                      <a:headEnd len="sm" w="sm" type="none"/>
-                      <a:tailEnd len="sm" w="sm" type="none"/>
-                    </a:lnT>
-                    <a:lnB cap="flat" cmpd="sng" w="9525">
-                      <a:solidFill>
-                        <a:schemeClr val="dk1"/>
-                      </a:solidFill>
-                      <a:prstDash val="solid"/>
-                      <a:round/>
-                      <a:headEnd len="sm" w="sm" type="none"/>
-                      <a:tailEnd len="sm" w="sm" type="none"/>
-                    </a:lnB>
-                  </a:tcPr>
-                </a:tc>
-              </a:tr>
-              <a:tr h="314250">
-                <a:tc>
-                  <a:txBody>
-                    <a:bodyPr/>
-                    <a:lstStyle/>
-                    <a:p>
-                      <a:pPr indent="0" lvl="0" marL="0" rtl="0" algn="l">
-                        <a:spcBef>
-                          <a:spcPts val="0"/>
-                        </a:spcBef>
-                        <a:spcAft>
-                          <a:spcPts val="0"/>
-                        </a:spcAft>
-                        <a:buNone/>
-                      </a:pPr>
-                      <a:r>
-                        <a:rPr lang="en" sz="1000"/>
-                        <a:t>Ring 8, NVLink, 1 node</a:t>
+                        <a:t>IB 31 GB/s</a:t>
                       </a:r>
                       <a:endParaRPr sz="1000"/>
                     </a:p>
@@ -9515,7 +9396,7 @@
                       </a:pPr>
                       <a:r>
                         <a:rPr lang="en" sz="1000"/>
-                        <a:t>11% / 7%</a:t>
+                        <a:t>NVL72</a:t>
                       </a:r>
                       <a:endParaRPr sz="1000"/>
                     </a:p>
@@ -9575,7 +9456,7 @@
                       </a:pPr>
                       <a:r>
                         <a:rPr lang="en" sz="1000"/>
-                        <a:t>6% / 2%</a:t>
+                        <a:t>Glass</a:t>
                       </a:r>
                       <a:endParaRPr sz="1000"/>
                     </a:p>
@@ -9620,7 +9501,7 @@
                   </a:tcPr>
                 </a:tc>
               </a:tr>
-              <a:tr h="314250">
+              <a:tr h="256032">
                 <a:tc>
                   <a:txBody>
                     <a:bodyPr/>
@@ -9637,7 +9518,7 @@
                       </a:pPr>
                       <a:r>
                         <a:rPr lang="en" sz="1000"/>
-                        <a:t>Ring 8, IB, 2 nodes, NCCL default</a:t>
+                        <a:t>Dense 5 s, Ulysses 4×ring 2</a:t>
                       </a:r>
                       <a:endParaRPr sz="1000"/>
                     </a:p>
@@ -9697,7 +9578,249 @@
                       </a:pPr>
                       <a:r>
                         <a:rPr lang="en" sz="1000"/>
-                        <a:t>73% / 54%</a:t>
+                        <a:t>8</a:t>
+                      </a:r>
+                      <a:endParaRPr sz="1000"/>
+                    </a:p>
+                  </a:txBody>
+                  <a:tcPr marT="91425" marB="91425" marR="91425" marL="91425">
+                    <a:lnL cap="flat" cmpd="sng" w="9525">
+                      <a:solidFill>
+                        <a:schemeClr val="dk1"/>
+                      </a:solidFill>
+                      <a:prstDash val="solid"/>
+                      <a:round/>
+                      <a:headEnd len="sm" w="sm" type="none"/>
+                      <a:tailEnd len="sm" w="sm" type="none"/>
+                    </a:lnL>
+                    <a:lnR cap="flat" cmpd="sng" w="9525">
+                      <a:solidFill>
+                        <a:schemeClr val="dk1"/>
+                      </a:solidFill>
+                      <a:prstDash val="solid"/>
+                      <a:round/>
+                      <a:headEnd len="sm" w="sm" type="none"/>
+                      <a:tailEnd len="sm" w="sm" type="none"/>
+                    </a:lnR>
+                    <a:lnT cap="flat" cmpd="sng" w="9525">
+                      <a:solidFill>
+                        <a:schemeClr val="dk1"/>
+                      </a:solidFill>
+                      <a:prstDash val="solid"/>
+                      <a:round/>
+                      <a:headEnd len="sm" w="sm" type="none"/>
+                      <a:tailEnd len="sm" w="sm" type="none"/>
+                    </a:lnT>
+                    <a:lnB cap="flat" cmpd="sng" w="9525">
+                      <a:solidFill>
+                        <a:schemeClr val="dk1"/>
+                      </a:solidFill>
+                      <a:prstDash val="solid"/>
+                      <a:round/>
+                      <a:headEnd len="sm" w="sm" type="none"/>
+                      <a:tailEnd len="sm" w="sm" type="none"/>
+                    </a:lnB>
+                  </a:tcPr>
+                </a:tc>
+                <a:tc>
+                  <a:txBody>
+                    <a:bodyPr/>
+                    <a:lstStyle/>
+                    <a:p>
+                      <a:pPr indent="0" lvl="0" marL="0" rtl="0" algn="l">
+                        <a:spcBef>
+                          <a:spcPts val="0"/>
+                        </a:spcBef>
+                        <a:spcAft>
+                          <a:spcPts val="0"/>
+                        </a:spcAft>
+                        <a:buNone/>
+                      </a:pPr>
+                      <a:r>
+                        <a:rPr lang="en" sz="1000" b="1"/>
+                        <a:t>1%</a:t>
+                      </a:r>
+                      <a:endParaRPr sz="1000"/>
+                    </a:p>
+                  </a:txBody>
+                  <a:tcPr marT="91425" marB="91425" marR="91425" marL="91425">
+                    <a:lnL cap="flat" cmpd="sng" w="9525">
+                      <a:solidFill>
+                        <a:schemeClr val="dk1"/>
+                      </a:solidFill>
+                      <a:prstDash val="solid"/>
+                      <a:round/>
+                      <a:headEnd len="sm" w="sm" type="none"/>
+                      <a:tailEnd len="sm" w="sm" type="none"/>
+                    </a:lnL>
+                    <a:lnR cap="flat" cmpd="sng" w="9525">
+                      <a:solidFill>
+                        <a:schemeClr val="dk1"/>
+                      </a:solidFill>
+                      <a:prstDash val="solid"/>
+                      <a:round/>
+                      <a:headEnd len="sm" w="sm" type="none"/>
+                      <a:tailEnd len="sm" w="sm" type="none"/>
+                    </a:lnR>
+                    <a:lnT cap="flat" cmpd="sng" w="9525">
+                      <a:solidFill>
+                        <a:schemeClr val="dk1"/>
+                      </a:solidFill>
+                      <a:prstDash val="solid"/>
+                      <a:round/>
+                      <a:headEnd len="sm" w="sm" type="none"/>
+                      <a:tailEnd len="sm" w="sm" type="none"/>
+                    </a:lnT>
+                    <a:lnB cap="flat" cmpd="sng" w="9525">
+                      <a:solidFill>
+                        <a:schemeClr val="dk1"/>
+                      </a:solidFill>
+                      <a:prstDash val="solid"/>
+                      <a:round/>
+                      <a:headEnd len="sm" w="sm" type="none"/>
+                      <a:tailEnd len="sm" w="sm" type="none"/>
+                    </a:lnB>
+                  </a:tcPr>
+                </a:tc>
+                <a:tc>
+                  <a:txBody>
+                    <a:bodyPr/>
+                    <a:lstStyle/>
+                    <a:p>
+                      <a:pPr indent="0" lvl="0" marL="0" rtl="0" algn="l">
+                        <a:spcBef>
+                          <a:spcPts val="0"/>
+                        </a:spcBef>
+                        <a:spcAft>
+                          <a:spcPts val="0"/>
+                        </a:spcAft>
+                        <a:buNone/>
+                      </a:pPr>
+                      <a:r>
+                        <a:rPr lang="en" sz="1000" b="1"/>
+                        <a:t>–</a:t>
+                      </a:r>
+                      <a:endParaRPr sz="1000"/>
+                    </a:p>
+                  </a:txBody>
+                  <a:tcPr marT="91425" marB="91425" marR="91425" marL="91425">
+                    <a:lnL cap="flat" cmpd="sng" w="9525">
+                      <a:solidFill>
+                        <a:schemeClr val="dk1"/>
+                      </a:solidFill>
+                      <a:prstDash val="solid"/>
+                      <a:round/>
+                      <a:headEnd len="sm" w="sm" type="none"/>
+                      <a:tailEnd len="sm" w="sm" type="none"/>
+                    </a:lnL>
+                    <a:lnR cap="flat" cmpd="sng" w="9525">
+                      <a:solidFill>
+                        <a:schemeClr val="dk1"/>
+                      </a:solidFill>
+                      <a:prstDash val="solid"/>
+                      <a:round/>
+                      <a:headEnd len="sm" w="sm" type="none"/>
+                      <a:tailEnd len="sm" w="sm" type="none"/>
+                    </a:lnR>
+                    <a:lnT cap="flat" cmpd="sng" w="9525">
+                      <a:solidFill>
+                        <a:schemeClr val="dk1"/>
+                      </a:solidFill>
+                      <a:prstDash val="solid"/>
+                      <a:round/>
+                      <a:headEnd len="sm" w="sm" type="none"/>
+                      <a:tailEnd len="sm" w="sm" type="none"/>
+                    </a:lnT>
+                    <a:lnB cap="flat" cmpd="sng" w="9525">
+                      <a:solidFill>
+                        <a:schemeClr val="dk1"/>
+                      </a:solidFill>
+                      <a:prstDash val="solid"/>
+                      <a:round/>
+                      <a:headEnd len="sm" w="sm" type="none"/>
+                      <a:tailEnd len="sm" w="sm" type="none"/>
+                    </a:lnB>
+                  </a:tcPr>
+                </a:tc>
+                <a:tc>
+                  <a:txBody>
+                    <a:bodyPr/>
+                    <a:lstStyle/>
+                    <a:p>
+                      <a:pPr indent="0" lvl="0" marL="0" rtl="0" algn="l">
+                        <a:spcBef>
+                          <a:spcPts val="0"/>
+                        </a:spcBef>
+                        <a:spcAft>
+                          <a:spcPts val="0"/>
+                        </a:spcAft>
+                        <a:buNone/>
+                      </a:pPr>
+                      <a:r>
+                        <a:rPr lang="en" sz="1000" b="1"/>
+                        <a:t>–</a:t>
+                      </a:r>
+                      <a:endParaRPr sz="1000"/>
+                    </a:p>
+                  </a:txBody>
+                  <a:tcPr marT="91425" marB="91425" marR="91425" marL="91425">
+                    <a:lnL cap="flat" cmpd="sng" w="9525">
+                      <a:solidFill>
+                        <a:schemeClr val="dk1"/>
+                      </a:solidFill>
+                      <a:prstDash val="solid"/>
+                      <a:round/>
+                      <a:headEnd len="sm" w="sm" type="none"/>
+                      <a:tailEnd len="sm" w="sm" type="none"/>
+                    </a:lnL>
+                    <a:lnR cap="flat" cmpd="sng" w="9525">
+                      <a:solidFill>
+                        <a:schemeClr val="dk1"/>
+                      </a:solidFill>
+                      <a:prstDash val="solid"/>
+                      <a:round/>
+                      <a:headEnd len="sm" w="sm" type="none"/>
+                      <a:tailEnd len="sm" w="sm" type="none"/>
+                    </a:lnR>
+                    <a:lnT cap="flat" cmpd="sng" w="9525">
+                      <a:solidFill>
+                        <a:schemeClr val="dk1"/>
+                      </a:solidFill>
+                      <a:prstDash val="solid"/>
+                      <a:round/>
+                      <a:headEnd len="sm" w="sm" type="none"/>
+                      <a:tailEnd len="sm" w="sm" type="none"/>
+                    </a:lnT>
+                    <a:lnB cap="flat" cmpd="sng" w="9525">
+                      <a:solidFill>
+                        <a:schemeClr val="dk1"/>
+                      </a:solidFill>
+                      <a:prstDash val="solid"/>
+                      <a:round/>
+                      <a:headEnd len="sm" w="sm" type="none"/>
+                      <a:tailEnd len="sm" w="sm" type="none"/>
+                    </a:lnB>
+                  </a:tcPr>
+                </a:tc>
+              </a:tr>
+              <a:tr h="256032">
+                <a:tc>
+                  <a:txBody>
+                    <a:bodyPr/>
+                    <a:lstStyle/>
+                    <a:p>
+                      <a:pPr indent="0" lvl="0" marL="0" rtl="0" algn="l">
+                        <a:spcBef>
+                          <a:spcPts val="0"/>
+                        </a:spcBef>
+                        <a:spcAft>
+                          <a:spcPts val="0"/>
+                        </a:spcAft>
+                        <a:buNone/>
+                      </a:pPr>
+                      <a:r>
+                        <a:rPr lang="en" sz="1000"/>
+                        <a:t>Dense 10 s, Ulysses 8×ring 2</a:t>
                       </a:r>
                       <a:endParaRPr sz="1000"/>
                     </a:p>
@@ -9757,7 +9880,7 @@
                       </a:pPr>
                       <a:r>
                         <a:rPr lang="en" sz="1000"/>
-                        <a:t>12% / 10%</a:t>
+                        <a:t>16</a:t>
                       </a:r>
                       <a:endParaRPr sz="1000"/>
                     </a:p>
@@ -9801,8 +9924,200 @@
                     </a:lnB>
                   </a:tcPr>
                 </a:tc>
+                <a:tc>
+                  <a:txBody>
+                    <a:bodyPr/>
+                    <a:lstStyle/>
+                    <a:p>
+                      <a:pPr indent="0" lvl="0" marL="0" rtl="0" algn="l">
+                        <a:spcBef>
+                          <a:spcPts val="0"/>
+                        </a:spcBef>
+                        <a:spcAft>
+                          <a:spcPts val="0"/>
+                        </a:spcAft>
+                        <a:buNone/>
+                      </a:pPr>
+                      <a:r>
+                        <a:rPr lang="en" sz="1000">
+                          <a:solidFill>
+                            <a:srgbClr val="1F5FBF"/>
+                          </a:solidFill>
+                        </a:rPr>
+                        <a:t>1%</a:t>
+                      </a:r>
+                      <a:endParaRPr sz="1000"/>
+                    </a:p>
+                  </a:txBody>
+                  <a:tcPr marT="91425" marB="91425" marR="91425" marL="91425">
+                    <a:lnL cap="flat" cmpd="sng" w="9525">
+                      <a:solidFill>
+                        <a:schemeClr val="dk1"/>
+                      </a:solidFill>
+                      <a:prstDash val="solid"/>
+                      <a:round/>
+                      <a:headEnd len="sm" w="sm" type="none"/>
+                      <a:tailEnd len="sm" w="sm" type="none"/>
+                    </a:lnL>
+                    <a:lnR cap="flat" cmpd="sng" w="9525">
+                      <a:solidFill>
+                        <a:schemeClr val="dk1"/>
+                      </a:solidFill>
+                      <a:prstDash val="solid"/>
+                      <a:round/>
+                      <a:headEnd len="sm" w="sm" type="none"/>
+                      <a:tailEnd len="sm" w="sm" type="none"/>
+                    </a:lnR>
+                    <a:lnT cap="flat" cmpd="sng" w="9525">
+                      <a:solidFill>
+                        <a:schemeClr val="dk1"/>
+                      </a:solidFill>
+                      <a:prstDash val="solid"/>
+                      <a:round/>
+                      <a:headEnd len="sm" w="sm" type="none"/>
+                      <a:tailEnd len="sm" w="sm" type="none"/>
+                    </a:lnT>
+                    <a:lnB cap="flat" cmpd="sng" w="9525">
+                      <a:solidFill>
+                        <a:schemeClr val="dk1"/>
+                      </a:solidFill>
+                      <a:prstDash val="solid"/>
+                      <a:round/>
+                      <a:headEnd len="sm" w="sm" type="none"/>
+                      <a:tailEnd len="sm" w="sm" type="none"/>
+                    </a:lnB>
+                  </a:tcPr>
+                </a:tc>
+                <a:tc>
+                  <a:txBody>
+                    <a:bodyPr/>
+                    <a:lstStyle/>
+                    <a:p>
+                      <a:pPr indent="0" lvl="0" marL="0" rtl="0" algn="l">
+                        <a:spcBef>
+                          <a:spcPts val="0"/>
+                        </a:spcBef>
+                        <a:spcAft>
+                          <a:spcPts val="0"/>
+                        </a:spcAft>
+                        <a:buNone/>
+                      </a:pPr>
+                      <a:r>
+                        <a:rPr lang="en" sz="1000">
+                          <a:solidFill>
+                            <a:srgbClr val="1F5FBF"/>
+                          </a:solidFill>
+                        </a:rPr>
+                        <a:t>0%</a:t>
+                      </a:r>
+                      <a:endParaRPr sz="1000"/>
+                    </a:p>
+                  </a:txBody>
+                  <a:tcPr marT="91425" marB="91425" marR="91425" marL="91425">
+                    <a:lnL cap="flat" cmpd="sng" w="9525">
+                      <a:solidFill>
+                        <a:schemeClr val="dk1"/>
+                      </a:solidFill>
+                      <a:prstDash val="solid"/>
+                      <a:round/>
+                      <a:headEnd len="sm" w="sm" type="none"/>
+                      <a:tailEnd len="sm" w="sm" type="none"/>
+                    </a:lnL>
+                    <a:lnR cap="flat" cmpd="sng" w="9525">
+                      <a:solidFill>
+                        <a:schemeClr val="dk1"/>
+                      </a:solidFill>
+                      <a:prstDash val="solid"/>
+                      <a:round/>
+                      <a:headEnd len="sm" w="sm" type="none"/>
+                      <a:tailEnd len="sm" w="sm" type="none"/>
+                    </a:lnR>
+                    <a:lnT cap="flat" cmpd="sng" w="9525">
+                      <a:solidFill>
+                        <a:schemeClr val="dk1"/>
+                      </a:solidFill>
+                      <a:prstDash val="solid"/>
+                      <a:round/>
+                      <a:headEnd len="sm" w="sm" type="none"/>
+                      <a:tailEnd len="sm" w="sm" type="none"/>
+                    </a:lnT>
+                    <a:lnB cap="flat" cmpd="sng" w="9525">
+                      <a:solidFill>
+                        <a:schemeClr val="dk1"/>
+                      </a:solidFill>
+                      <a:prstDash val="solid"/>
+                      <a:round/>
+                      <a:headEnd len="sm" w="sm" type="none"/>
+                      <a:tailEnd len="sm" w="sm" type="none"/>
+                    </a:lnB>
+                  </a:tcPr>
+                </a:tc>
+                <a:tc>
+                  <a:txBody>
+                    <a:bodyPr/>
+                    <a:lstStyle/>
+                    <a:p>
+                      <a:pPr indent="0" lvl="0" marL="0" rtl="0" algn="l">
+                        <a:spcBef>
+                          <a:spcPts val="0"/>
+                        </a:spcBef>
+                        <a:spcAft>
+                          <a:spcPts val="0"/>
+                        </a:spcAft>
+                        <a:buNone/>
+                      </a:pPr>
+                      <a:r>
+                        <a:rPr lang="en" sz="1000">
+                          <a:solidFill>
+                            <a:srgbClr val="1F5FBF"/>
+                          </a:solidFill>
+                        </a:rPr>
+                        <a:t>0%</a:t>
+                      </a:r>
+                      <a:endParaRPr sz="1000"/>
+                    </a:p>
+                  </a:txBody>
+                  <a:tcPr marT="91425" marB="91425" marR="91425" marL="91425">
+                    <a:lnL cap="flat" cmpd="sng" w="9525">
+                      <a:solidFill>
+                        <a:schemeClr val="dk1"/>
+                      </a:solidFill>
+                      <a:prstDash val="solid"/>
+                      <a:round/>
+                      <a:headEnd len="sm" w="sm" type="none"/>
+                      <a:tailEnd len="sm" w="sm" type="none"/>
+                    </a:lnL>
+                    <a:lnR cap="flat" cmpd="sng" w="9525">
+                      <a:solidFill>
+                        <a:schemeClr val="dk1"/>
+                      </a:solidFill>
+                      <a:prstDash val="solid"/>
+                      <a:round/>
+                      <a:headEnd len="sm" w="sm" type="none"/>
+                      <a:tailEnd len="sm" w="sm" type="none"/>
+                    </a:lnR>
+                    <a:lnT cap="flat" cmpd="sng" w="9525">
+                      <a:solidFill>
+                        <a:schemeClr val="dk1"/>
+                      </a:solidFill>
+                      <a:prstDash val="solid"/>
+                      <a:round/>
+                      <a:headEnd len="sm" w="sm" type="none"/>
+                      <a:tailEnd len="sm" w="sm" type="none"/>
+                    </a:lnT>
+                    <a:lnB cap="flat" cmpd="sng" w="9525">
+                      <a:solidFill>
+                        <a:schemeClr val="dk1"/>
+                      </a:solidFill>
+                      <a:prstDash val="solid"/>
+                      <a:round/>
+                      <a:headEnd len="sm" w="sm" type="none"/>
+                      <a:tailEnd len="sm" w="sm" type="none"/>
+                    </a:lnB>
+                  </a:tcPr>
+                </a:tc>
               </a:tr>
-              <a:tr h="314250">
+              <a:tr h="256032">
                 <a:tc>
                   <a:txBody>
                     <a:bodyPr/>
@@ -9819,7 +10134,7 @@
                       </a:pPr>
                       <a:r>
                         <a:rPr lang="en" sz="1000"/>
-                        <a:t>Ring 8, IB, 2 nodes, 4 ch/peer</a:t>
+                        <a:t>Sparse 10 s, Ulysses 8×ring 2</a:t>
                       </a:r>
                       <a:endParaRPr sz="1000"/>
                     </a:p>
@@ -9879,7 +10194,261 @@
                       </a:pPr>
                       <a:r>
                         <a:rPr lang="en" sz="1000"/>
-                        <a:t>45% / 36%</a:t>
+                        <a:t>16</a:t>
+                      </a:r>
+                      <a:endParaRPr sz="1000"/>
+                    </a:p>
+                  </a:txBody>
+                  <a:tcPr marT="91425" marB="91425" marR="91425" marL="91425">
+                    <a:lnL cap="flat" cmpd="sng" w="9525">
+                      <a:solidFill>
+                        <a:schemeClr val="dk1"/>
+                      </a:solidFill>
+                      <a:prstDash val="solid"/>
+                      <a:round/>
+                      <a:headEnd len="sm" w="sm" type="none"/>
+                      <a:tailEnd len="sm" w="sm" type="none"/>
+                    </a:lnL>
+                    <a:lnR cap="flat" cmpd="sng" w="9525">
+                      <a:solidFill>
+                        <a:schemeClr val="dk1"/>
+                      </a:solidFill>
+                      <a:prstDash val="solid"/>
+                      <a:round/>
+                      <a:headEnd len="sm" w="sm" type="none"/>
+                      <a:tailEnd len="sm" w="sm" type="none"/>
+                    </a:lnR>
+                    <a:lnT cap="flat" cmpd="sng" w="9525">
+                      <a:solidFill>
+                        <a:schemeClr val="dk1"/>
+                      </a:solidFill>
+                      <a:prstDash val="solid"/>
+                      <a:round/>
+                      <a:headEnd len="sm" w="sm" type="none"/>
+                      <a:tailEnd len="sm" w="sm" type="none"/>
+                    </a:lnT>
+                    <a:lnB cap="flat" cmpd="sng" w="9525">
+                      <a:solidFill>
+                        <a:schemeClr val="dk1"/>
+                      </a:solidFill>
+                      <a:prstDash val="solid"/>
+                      <a:round/>
+                      <a:headEnd len="sm" w="sm" type="none"/>
+                      <a:tailEnd len="sm" w="sm" type="none"/>
+                    </a:lnB>
+                  </a:tcPr>
+                </a:tc>
+                <a:tc>
+                  <a:txBody>
+                    <a:bodyPr/>
+                    <a:lstStyle/>
+                    <a:p>
+                      <a:pPr indent="0" lvl="0" marL="0" rtl="0" algn="l">
+                        <a:spcBef>
+                          <a:spcPts val="0"/>
+                        </a:spcBef>
+                        <a:spcAft>
+                          <a:spcPts val="0"/>
+                        </a:spcAft>
+                        <a:buNone/>
+                      </a:pPr>
+                      <a:r>
+                        <a:rPr lang="en" sz="1000">
+                          <a:solidFill>
+                            <a:srgbClr val="1F5FBF"/>
+                          </a:solidFill>
+                        </a:rPr>
+                        <a:t>5%</a:t>
+                      </a:r>
+                      <a:endParaRPr sz="1000"/>
+                    </a:p>
+                  </a:txBody>
+                  <a:tcPr marT="91425" marB="91425" marR="91425" marL="91425">
+                    <a:lnL cap="flat" cmpd="sng" w="9525">
+                      <a:solidFill>
+                        <a:schemeClr val="dk1"/>
+                      </a:solidFill>
+                      <a:prstDash val="solid"/>
+                      <a:round/>
+                      <a:headEnd len="sm" w="sm" type="none"/>
+                      <a:tailEnd len="sm" w="sm" type="none"/>
+                    </a:lnL>
+                    <a:lnR cap="flat" cmpd="sng" w="9525">
+                      <a:solidFill>
+                        <a:schemeClr val="dk1"/>
+                      </a:solidFill>
+                      <a:prstDash val="solid"/>
+                      <a:round/>
+                      <a:headEnd len="sm" w="sm" type="none"/>
+                      <a:tailEnd len="sm" w="sm" type="none"/>
+                    </a:lnR>
+                    <a:lnT cap="flat" cmpd="sng" w="9525">
+                      <a:solidFill>
+                        <a:schemeClr val="dk1"/>
+                      </a:solidFill>
+                      <a:prstDash val="solid"/>
+                      <a:round/>
+                      <a:headEnd len="sm" w="sm" type="none"/>
+                      <a:tailEnd len="sm" w="sm" type="none"/>
+                    </a:lnT>
+                    <a:lnB cap="flat" cmpd="sng" w="9525">
+                      <a:solidFill>
+                        <a:schemeClr val="dk1"/>
+                      </a:solidFill>
+                      <a:prstDash val="solid"/>
+                      <a:round/>
+                      <a:headEnd len="sm" w="sm" type="none"/>
+                      <a:tailEnd len="sm" w="sm" type="none"/>
+                    </a:lnB>
+                  </a:tcPr>
+                </a:tc>
+                <a:tc>
+                  <a:txBody>
+                    <a:bodyPr/>
+                    <a:lstStyle/>
+                    <a:p>
+                      <a:pPr indent="0" lvl="0" marL="0" rtl="0" algn="l">
+                        <a:spcBef>
+                          <a:spcPts val="0"/>
+                        </a:spcBef>
+                        <a:spcAft>
+                          <a:spcPts val="0"/>
+                        </a:spcAft>
+                        <a:buNone/>
+                      </a:pPr>
+                      <a:r>
+                        <a:rPr lang="en" sz="1000">
+                          <a:solidFill>
+                            <a:srgbClr val="1F5FBF"/>
+                          </a:solidFill>
+                        </a:rPr>
+                        <a:t>1%</a:t>
+                      </a:r>
+                      <a:endParaRPr sz="1000"/>
+                    </a:p>
+                  </a:txBody>
+                  <a:tcPr marT="91425" marB="91425" marR="91425" marL="91425">
+                    <a:lnL cap="flat" cmpd="sng" w="9525">
+                      <a:solidFill>
+                        <a:schemeClr val="dk1"/>
+                      </a:solidFill>
+                      <a:prstDash val="solid"/>
+                      <a:round/>
+                      <a:headEnd len="sm" w="sm" type="none"/>
+                      <a:tailEnd len="sm" w="sm" type="none"/>
+                    </a:lnL>
+                    <a:lnR cap="flat" cmpd="sng" w="9525">
+                      <a:solidFill>
+                        <a:schemeClr val="dk1"/>
+                      </a:solidFill>
+                      <a:prstDash val="solid"/>
+                      <a:round/>
+                      <a:headEnd len="sm" w="sm" type="none"/>
+                      <a:tailEnd len="sm" w="sm" type="none"/>
+                    </a:lnR>
+                    <a:lnT cap="flat" cmpd="sng" w="9525">
+                      <a:solidFill>
+                        <a:schemeClr val="dk1"/>
+                      </a:solidFill>
+                      <a:prstDash val="solid"/>
+                      <a:round/>
+                      <a:headEnd len="sm" w="sm" type="none"/>
+                      <a:tailEnd len="sm" w="sm" type="none"/>
+                    </a:lnT>
+                    <a:lnB cap="flat" cmpd="sng" w="9525">
+                      <a:solidFill>
+                        <a:schemeClr val="dk1"/>
+                      </a:solidFill>
+                      <a:prstDash val="solid"/>
+                      <a:round/>
+                      <a:headEnd len="sm" w="sm" type="none"/>
+                      <a:tailEnd len="sm" w="sm" type="none"/>
+                    </a:lnB>
+                  </a:tcPr>
+                </a:tc>
+                <a:tc>
+                  <a:txBody>
+                    <a:bodyPr/>
+                    <a:lstStyle/>
+                    <a:p>
+                      <a:pPr indent="0" lvl="0" marL="0" rtl="0" algn="l">
+                        <a:spcBef>
+                          <a:spcPts val="0"/>
+                        </a:spcBef>
+                        <a:spcAft>
+                          <a:spcPts val="0"/>
+                        </a:spcAft>
+                        <a:buNone/>
+                      </a:pPr>
+                      <a:r>
+                        <a:rPr lang="en" sz="1000">
+                          <a:solidFill>
+                            <a:srgbClr val="1F5FBF"/>
+                          </a:solidFill>
+                        </a:rPr>
+                        <a:t>0%</a:t>
+                      </a:r>
+                      <a:endParaRPr sz="1000"/>
+                    </a:p>
+                  </a:txBody>
+                  <a:tcPr marT="91425" marB="91425" marR="91425" marL="91425">
+                    <a:lnL cap="flat" cmpd="sng" w="9525">
+                      <a:solidFill>
+                        <a:schemeClr val="dk1"/>
+                      </a:solidFill>
+                      <a:prstDash val="solid"/>
+                      <a:round/>
+                      <a:headEnd len="sm" w="sm" type="none"/>
+                      <a:tailEnd len="sm" w="sm" type="none"/>
+                    </a:lnL>
+                    <a:lnR cap="flat" cmpd="sng" w="9525">
+                      <a:solidFill>
+                        <a:schemeClr val="dk1"/>
+                      </a:solidFill>
+                      <a:prstDash val="solid"/>
+                      <a:round/>
+                      <a:headEnd len="sm" w="sm" type="none"/>
+                      <a:tailEnd len="sm" w="sm" type="none"/>
+                    </a:lnR>
+                    <a:lnT cap="flat" cmpd="sng" w="9525">
+                      <a:solidFill>
+                        <a:schemeClr val="dk1"/>
+                      </a:solidFill>
+                      <a:prstDash val="solid"/>
+                      <a:round/>
+                      <a:headEnd len="sm" w="sm" type="none"/>
+                      <a:tailEnd len="sm" w="sm" type="none"/>
+                    </a:lnT>
+                    <a:lnB cap="flat" cmpd="sng" w="9525">
+                      <a:solidFill>
+                        <a:schemeClr val="dk1"/>
+                      </a:solidFill>
+                      <a:prstDash val="solid"/>
+                      <a:round/>
+                      <a:headEnd len="sm" w="sm" type="none"/>
+                      <a:tailEnd len="sm" w="sm" type="none"/>
+                    </a:lnB>
+                  </a:tcPr>
+                </a:tc>
+              </a:tr>
+              <a:tr h="256032">
+                <a:tc>
+                  <a:txBody>
+                    <a:bodyPr/>
+                    <a:lstStyle/>
+                    <a:p>
+                      <a:pPr indent="0" lvl="0" marL="0" rtl="0" algn="l">
+                        <a:spcBef>
+                          <a:spcPts val="0"/>
+                        </a:spcBef>
+                        <a:spcAft>
+                          <a:spcPts val="0"/>
+                        </a:spcAft>
+                        <a:buNone/>
+                      </a:pPr>
+                      <a:r>
+                        <a:rPr lang="en" sz="1000"/>
+                        <a:t>Dense 5 s, Ulysses 8×ring 8</a:t>
                       </a:r>
                       <a:endParaRPr sz="1000"/>
                     </a:p>
@@ -9939,7 +10508,7 @@
                       </a:pPr>
                       <a:r>
                         <a:rPr lang="en" sz="1000"/>
-                        <a:t>3% / 5%</a:t>
+                        <a:t>64</a:t>
                       </a:r>
                       <a:endParaRPr sz="1000"/>
                     </a:p>
@@ -9983,8 +10552,200 @@
                     </a:lnB>
                   </a:tcPr>
                 </a:tc>
+                <a:tc>
+                  <a:txBody>
+                    <a:bodyPr/>
+                    <a:lstStyle/>
+                    <a:p>
+                      <a:pPr indent="0" lvl="0" marL="0" rtl="0" algn="l">
+                        <a:spcBef>
+                          <a:spcPts val="0"/>
+                        </a:spcBef>
+                        <a:spcAft>
+                          <a:spcPts val="0"/>
+                        </a:spcAft>
+                        <a:buNone/>
+                      </a:pPr>
+                      <a:r>
+                        <a:rPr lang="en" sz="1000">
+                          <a:solidFill>
+                            <a:srgbClr val="1F5FBF"/>
+                          </a:solidFill>
+                        </a:rPr>
+                        <a:t>18%</a:t>
+                      </a:r>
+                      <a:endParaRPr sz="1000"/>
+                    </a:p>
+                  </a:txBody>
+                  <a:tcPr marT="91425" marB="91425" marR="91425" marL="91425">
+                    <a:lnL cap="flat" cmpd="sng" w="9525">
+                      <a:solidFill>
+                        <a:schemeClr val="dk1"/>
+                      </a:solidFill>
+                      <a:prstDash val="solid"/>
+                      <a:round/>
+                      <a:headEnd len="sm" w="sm" type="none"/>
+                      <a:tailEnd len="sm" w="sm" type="none"/>
+                    </a:lnL>
+                    <a:lnR cap="flat" cmpd="sng" w="9525">
+                      <a:solidFill>
+                        <a:schemeClr val="dk1"/>
+                      </a:solidFill>
+                      <a:prstDash val="solid"/>
+                      <a:round/>
+                      <a:headEnd len="sm" w="sm" type="none"/>
+                      <a:tailEnd len="sm" w="sm" type="none"/>
+                    </a:lnR>
+                    <a:lnT cap="flat" cmpd="sng" w="9525">
+                      <a:solidFill>
+                        <a:schemeClr val="dk1"/>
+                      </a:solidFill>
+                      <a:prstDash val="solid"/>
+                      <a:round/>
+                      <a:headEnd len="sm" w="sm" type="none"/>
+                      <a:tailEnd len="sm" w="sm" type="none"/>
+                    </a:lnT>
+                    <a:lnB cap="flat" cmpd="sng" w="9525">
+                      <a:solidFill>
+                        <a:schemeClr val="dk1"/>
+                      </a:solidFill>
+                      <a:prstDash val="solid"/>
+                      <a:round/>
+                      <a:headEnd len="sm" w="sm" type="none"/>
+                      <a:tailEnd len="sm" w="sm" type="none"/>
+                    </a:lnB>
+                  </a:tcPr>
+                </a:tc>
+                <a:tc>
+                  <a:txBody>
+                    <a:bodyPr/>
+                    <a:lstStyle/>
+                    <a:p>
+                      <a:pPr indent="0" lvl="0" marL="0" rtl="0" algn="l">
+                        <a:spcBef>
+                          <a:spcPts val="0"/>
+                        </a:spcBef>
+                        <a:spcAft>
+                          <a:spcPts val="0"/>
+                        </a:spcAft>
+                        <a:buNone/>
+                      </a:pPr>
+                      <a:r>
+                        <a:rPr lang="en" sz="1000">
+                          <a:solidFill>
+                            <a:srgbClr val="1F5FBF"/>
+                          </a:solidFill>
+                        </a:rPr>
+                        <a:t>12%</a:t>
+                      </a:r>
+                      <a:endParaRPr sz="1000"/>
+                    </a:p>
+                  </a:txBody>
+                  <a:tcPr marT="91425" marB="91425" marR="91425" marL="91425">
+                    <a:lnL cap="flat" cmpd="sng" w="9525">
+                      <a:solidFill>
+                        <a:schemeClr val="dk1"/>
+                      </a:solidFill>
+                      <a:prstDash val="solid"/>
+                      <a:round/>
+                      <a:headEnd len="sm" w="sm" type="none"/>
+                      <a:tailEnd len="sm" w="sm" type="none"/>
+                    </a:lnL>
+                    <a:lnR cap="flat" cmpd="sng" w="9525">
+                      <a:solidFill>
+                        <a:schemeClr val="dk1"/>
+                      </a:solidFill>
+                      <a:prstDash val="solid"/>
+                      <a:round/>
+                      <a:headEnd len="sm" w="sm" type="none"/>
+                      <a:tailEnd len="sm" w="sm" type="none"/>
+                    </a:lnR>
+                    <a:lnT cap="flat" cmpd="sng" w="9525">
+                      <a:solidFill>
+                        <a:schemeClr val="dk1"/>
+                      </a:solidFill>
+                      <a:prstDash val="solid"/>
+                      <a:round/>
+                      <a:headEnd len="sm" w="sm" type="none"/>
+                      <a:tailEnd len="sm" w="sm" type="none"/>
+                    </a:lnT>
+                    <a:lnB cap="flat" cmpd="sng" w="9525">
+                      <a:solidFill>
+                        <a:schemeClr val="dk1"/>
+                      </a:solidFill>
+                      <a:prstDash val="solid"/>
+                      <a:round/>
+                      <a:headEnd len="sm" w="sm" type="none"/>
+                      <a:tailEnd len="sm" w="sm" type="none"/>
+                    </a:lnB>
+                  </a:tcPr>
+                </a:tc>
+                <a:tc>
+                  <a:txBody>
+                    <a:bodyPr/>
+                    <a:lstStyle/>
+                    <a:p>
+                      <a:pPr indent="0" lvl="0" marL="0" rtl="0" algn="l">
+                        <a:spcBef>
+                          <a:spcPts val="0"/>
+                        </a:spcBef>
+                        <a:spcAft>
+                          <a:spcPts val="0"/>
+                        </a:spcAft>
+                        <a:buNone/>
+                      </a:pPr>
+                      <a:r>
+                        <a:rPr lang="en" sz="1000">
+                          <a:solidFill>
+                            <a:srgbClr val="1F5FBF"/>
+                          </a:solidFill>
+                        </a:rPr>
+                        <a:t>12%</a:t>
+                      </a:r>
+                      <a:endParaRPr sz="1000"/>
+                    </a:p>
+                  </a:txBody>
+                  <a:tcPr marT="91425" marB="91425" marR="91425" marL="91425">
+                    <a:lnL cap="flat" cmpd="sng" w="9525">
+                      <a:solidFill>
+                        <a:schemeClr val="dk1"/>
+                      </a:solidFill>
+                      <a:prstDash val="solid"/>
+                      <a:round/>
+                      <a:headEnd len="sm" w="sm" type="none"/>
+                      <a:tailEnd len="sm" w="sm" type="none"/>
+                    </a:lnL>
+                    <a:lnR cap="flat" cmpd="sng" w="9525">
+                      <a:solidFill>
+                        <a:schemeClr val="dk1"/>
+                      </a:solidFill>
+                      <a:prstDash val="solid"/>
+                      <a:round/>
+                      <a:headEnd len="sm" w="sm" type="none"/>
+                      <a:tailEnd len="sm" w="sm" type="none"/>
+                    </a:lnR>
+                    <a:lnT cap="flat" cmpd="sng" w="9525">
+                      <a:solidFill>
+                        <a:schemeClr val="dk1"/>
+                      </a:solidFill>
+                      <a:prstDash val="solid"/>
+                      <a:round/>
+                      <a:headEnd len="sm" w="sm" type="none"/>
+                      <a:tailEnd len="sm" w="sm" type="none"/>
+                    </a:lnT>
+                    <a:lnB cap="flat" cmpd="sng" w="9525">
+                      <a:solidFill>
+                        <a:schemeClr val="dk1"/>
+                      </a:solidFill>
+                      <a:prstDash val="solid"/>
+                      <a:round/>
+                      <a:headEnd len="sm" w="sm" type="none"/>
+                      <a:tailEnd len="sm" w="sm" type="none"/>
+                    </a:lnB>
+                  </a:tcPr>
+                </a:tc>
               </a:tr>
-              <a:tr h="314250">
+              <a:tr h="256032">
                 <a:tc>
                   <a:txBody>
                     <a:bodyPr/>
@@ -10001,7 +10762,7 @@
                       </a:pPr>
                       <a:r>
                         <a:rPr lang="en" sz="1000"/>
-                        <a:t>Ulysses 4 x ring 2, 2 nodes</a:t>
+                        <a:t>Sparse 5 s, Ulysses 8×ring 8</a:t>
                       </a:r>
                       <a:endParaRPr sz="1000"/>
                     </a:p>
@@ -10061,7 +10822,261 @@
                       </a:pPr>
                       <a:r>
                         <a:rPr lang="en" sz="1000"/>
-                        <a:t>16% / 14%</a:t>
+                        <a:t>64</a:t>
+                      </a:r>
+                      <a:endParaRPr sz="1000"/>
+                    </a:p>
+                  </a:txBody>
+                  <a:tcPr marT="91425" marB="91425" marR="91425" marL="91425">
+                    <a:lnL cap="flat" cmpd="sng" w="9525">
+                      <a:solidFill>
+                        <a:schemeClr val="dk1"/>
+                      </a:solidFill>
+                      <a:prstDash val="solid"/>
+                      <a:round/>
+                      <a:headEnd len="sm" w="sm" type="none"/>
+                      <a:tailEnd len="sm" w="sm" type="none"/>
+                    </a:lnL>
+                    <a:lnR cap="flat" cmpd="sng" w="9525">
+                      <a:solidFill>
+                        <a:schemeClr val="dk1"/>
+                      </a:solidFill>
+                      <a:prstDash val="solid"/>
+                      <a:round/>
+                      <a:headEnd len="sm" w="sm" type="none"/>
+                      <a:tailEnd len="sm" w="sm" type="none"/>
+                    </a:lnR>
+                    <a:lnT cap="flat" cmpd="sng" w="9525">
+                      <a:solidFill>
+                        <a:schemeClr val="dk1"/>
+                      </a:solidFill>
+                      <a:prstDash val="solid"/>
+                      <a:round/>
+                      <a:headEnd len="sm" w="sm" type="none"/>
+                      <a:tailEnd len="sm" w="sm" type="none"/>
+                    </a:lnT>
+                    <a:lnB cap="flat" cmpd="sng" w="9525">
+                      <a:solidFill>
+                        <a:schemeClr val="dk1"/>
+                      </a:solidFill>
+                      <a:prstDash val="solid"/>
+                      <a:round/>
+                      <a:headEnd len="sm" w="sm" type="none"/>
+                      <a:tailEnd len="sm" w="sm" type="none"/>
+                    </a:lnB>
+                  </a:tcPr>
+                </a:tc>
+                <a:tc>
+                  <a:txBody>
+                    <a:bodyPr/>
+                    <a:lstStyle/>
+                    <a:p>
+                      <a:pPr indent="0" lvl="0" marL="0" rtl="0" algn="l">
+                        <a:spcBef>
+                          <a:spcPts val="0"/>
+                        </a:spcBef>
+                        <a:spcAft>
+                          <a:spcPts val="0"/>
+                        </a:spcAft>
+                        <a:buNone/>
+                      </a:pPr>
+                      <a:r>
+                        <a:rPr lang="en" sz="1000">
+                          <a:solidFill>
+                            <a:srgbClr val="1F5FBF"/>
+                          </a:solidFill>
+                        </a:rPr>
+                        <a:t>56%</a:t>
+                      </a:r>
+                      <a:endParaRPr sz="1000"/>
+                    </a:p>
+                  </a:txBody>
+                  <a:tcPr marT="91425" marB="91425" marR="91425" marL="91425">
+                    <a:lnL cap="flat" cmpd="sng" w="9525">
+                      <a:solidFill>
+                        <a:schemeClr val="dk1"/>
+                      </a:solidFill>
+                      <a:prstDash val="solid"/>
+                      <a:round/>
+                      <a:headEnd len="sm" w="sm" type="none"/>
+                      <a:tailEnd len="sm" w="sm" type="none"/>
+                    </a:lnL>
+                    <a:lnR cap="flat" cmpd="sng" w="9525">
+                      <a:solidFill>
+                        <a:schemeClr val="dk1"/>
+                      </a:solidFill>
+                      <a:prstDash val="solid"/>
+                      <a:round/>
+                      <a:headEnd len="sm" w="sm" type="none"/>
+                      <a:tailEnd len="sm" w="sm" type="none"/>
+                    </a:lnR>
+                    <a:lnT cap="flat" cmpd="sng" w="9525">
+                      <a:solidFill>
+                        <a:schemeClr val="dk1"/>
+                      </a:solidFill>
+                      <a:prstDash val="solid"/>
+                      <a:round/>
+                      <a:headEnd len="sm" w="sm" type="none"/>
+                      <a:tailEnd len="sm" w="sm" type="none"/>
+                    </a:lnT>
+                    <a:lnB cap="flat" cmpd="sng" w="9525">
+                      <a:solidFill>
+                        <a:schemeClr val="dk1"/>
+                      </a:solidFill>
+                      <a:prstDash val="solid"/>
+                      <a:round/>
+                      <a:headEnd len="sm" w="sm" type="none"/>
+                      <a:tailEnd len="sm" w="sm" type="none"/>
+                    </a:lnB>
+                  </a:tcPr>
+                </a:tc>
+                <a:tc>
+                  <a:txBody>
+                    <a:bodyPr/>
+                    <a:lstStyle/>
+                    <a:p>
+                      <a:pPr indent="0" lvl="0" marL="0" rtl="0" algn="l">
+                        <a:spcBef>
+                          <a:spcPts val="0"/>
+                        </a:spcBef>
+                        <a:spcAft>
+                          <a:spcPts val="0"/>
+                        </a:spcAft>
+                        <a:buNone/>
+                      </a:pPr>
+                      <a:r>
+                        <a:rPr lang="en" sz="1000">
+                          <a:solidFill>
+                            <a:srgbClr val="1F5FBF"/>
+                          </a:solidFill>
+                        </a:rPr>
+                        <a:t>14%</a:t>
+                      </a:r>
+                      <a:endParaRPr sz="1000"/>
+                    </a:p>
+                  </a:txBody>
+                  <a:tcPr marT="91425" marB="91425" marR="91425" marL="91425">
+                    <a:lnL cap="flat" cmpd="sng" w="9525">
+                      <a:solidFill>
+                        <a:schemeClr val="dk1"/>
+                      </a:solidFill>
+                      <a:prstDash val="solid"/>
+                      <a:round/>
+                      <a:headEnd len="sm" w="sm" type="none"/>
+                      <a:tailEnd len="sm" w="sm" type="none"/>
+                    </a:lnL>
+                    <a:lnR cap="flat" cmpd="sng" w="9525">
+                      <a:solidFill>
+                        <a:schemeClr val="dk1"/>
+                      </a:solidFill>
+                      <a:prstDash val="solid"/>
+                      <a:round/>
+                      <a:headEnd len="sm" w="sm" type="none"/>
+                      <a:tailEnd len="sm" w="sm" type="none"/>
+                    </a:lnR>
+                    <a:lnT cap="flat" cmpd="sng" w="9525">
+                      <a:solidFill>
+                        <a:schemeClr val="dk1"/>
+                      </a:solidFill>
+                      <a:prstDash val="solid"/>
+                      <a:round/>
+                      <a:headEnd len="sm" w="sm" type="none"/>
+                      <a:tailEnd len="sm" w="sm" type="none"/>
+                    </a:lnT>
+                    <a:lnB cap="flat" cmpd="sng" w="9525">
+                      <a:solidFill>
+                        <a:schemeClr val="dk1"/>
+                      </a:solidFill>
+                      <a:prstDash val="solid"/>
+                      <a:round/>
+                      <a:headEnd len="sm" w="sm" type="none"/>
+                      <a:tailEnd len="sm" w="sm" type="none"/>
+                    </a:lnB>
+                  </a:tcPr>
+                </a:tc>
+                <a:tc>
+                  <a:txBody>
+                    <a:bodyPr/>
+                    <a:lstStyle/>
+                    <a:p>
+                      <a:pPr indent="0" lvl="0" marL="0" rtl="0" algn="l">
+                        <a:spcBef>
+                          <a:spcPts val="0"/>
+                        </a:spcBef>
+                        <a:spcAft>
+                          <a:spcPts val="0"/>
+                        </a:spcAft>
+                        <a:buNone/>
+                      </a:pPr>
+                      <a:r>
+                        <a:rPr lang="en" sz="1000">
+                          <a:solidFill>
+                            <a:srgbClr val="1F5FBF"/>
+                          </a:solidFill>
+                        </a:rPr>
+                        <a:t>13%</a:t>
+                      </a:r>
+                      <a:endParaRPr sz="1000"/>
+                    </a:p>
+                  </a:txBody>
+                  <a:tcPr marT="91425" marB="91425" marR="91425" marL="91425">
+                    <a:lnL cap="flat" cmpd="sng" w="9525">
+                      <a:solidFill>
+                        <a:schemeClr val="dk1"/>
+                      </a:solidFill>
+                      <a:prstDash val="solid"/>
+                      <a:round/>
+                      <a:headEnd len="sm" w="sm" type="none"/>
+                      <a:tailEnd len="sm" w="sm" type="none"/>
+                    </a:lnL>
+                    <a:lnR cap="flat" cmpd="sng" w="9525">
+                      <a:solidFill>
+                        <a:schemeClr val="dk1"/>
+                      </a:solidFill>
+                      <a:prstDash val="solid"/>
+                      <a:round/>
+                      <a:headEnd len="sm" w="sm" type="none"/>
+                      <a:tailEnd len="sm" w="sm" type="none"/>
+                    </a:lnR>
+                    <a:lnT cap="flat" cmpd="sng" w="9525">
+                      <a:solidFill>
+                        <a:schemeClr val="dk1"/>
+                      </a:solidFill>
+                      <a:prstDash val="solid"/>
+                      <a:round/>
+                      <a:headEnd len="sm" w="sm" type="none"/>
+                      <a:tailEnd len="sm" w="sm" type="none"/>
+                    </a:lnT>
+                    <a:lnB cap="flat" cmpd="sng" w="9525">
+                      <a:solidFill>
+                        <a:schemeClr val="dk1"/>
+                      </a:solidFill>
+                      <a:prstDash val="solid"/>
+                      <a:round/>
+                      <a:headEnd len="sm" w="sm" type="none"/>
+                      <a:tailEnd len="sm" w="sm" type="none"/>
+                    </a:lnB>
+                  </a:tcPr>
+                </a:tc>
+              </a:tr>
+              <a:tr h="256032">
+                <a:tc>
+                  <a:txBody>
+                    <a:bodyPr/>
+                    <a:lstStyle/>
+                    <a:p>
+                      <a:pPr indent="0" lvl="0" marL="0" rtl="0" algn="l">
+                        <a:spcBef>
+                          <a:spcPts val="0"/>
+                        </a:spcBef>
+                        <a:spcAft>
+                          <a:spcPts val="0"/>
+                        </a:spcAft>
+                        <a:buNone/>
+                      </a:pPr>
+                      <a:r>
+                        <a:rPr lang="en" sz="1000"/>
+                        <a:t>Sparse + causal 5 s, Ulysses 8×ring 8</a:t>
                       </a:r>
                       <a:endParaRPr sz="1000"/>
                     </a:p>
@@ -10121,7 +11136,199 @@
                       </a:pPr>
                       <a:r>
                         <a:rPr lang="en" sz="1000"/>
-                        <a:t>2% / 2%</a:t>
+                        <a:t>64</a:t>
+                      </a:r>
+                      <a:endParaRPr sz="1000"/>
+                    </a:p>
+                  </a:txBody>
+                  <a:tcPr marT="91425" marB="91425" marR="91425" marL="91425">
+                    <a:lnL cap="flat" cmpd="sng" w="9525">
+                      <a:solidFill>
+                        <a:schemeClr val="dk1"/>
+                      </a:solidFill>
+                      <a:prstDash val="solid"/>
+                      <a:round/>
+                      <a:headEnd len="sm" w="sm" type="none"/>
+                      <a:tailEnd len="sm" w="sm" type="none"/>
+                    </a:lnL>
+                    <a:lnR cap="flat" cmpd="sng" w="9525">
+                      <a:solidFill>
+                        <a:schemeClr val="dk1"/>
+                      </a:solidFill>
+                      <a:prstDash val="solid"/>
+                      <a:round/>
+                      <a:headEnd len="sm" w="sm" type="none"/>
+                      <a:tailEnd len="sm" w="sm" type="none"/>
+                    </a:lnR>
+                    <a:lnT cap="flat" cmpd="sng" w="9525">
+                      <a:solidFill>
+                        <a:schemeClr val="dk1"/>
+                      </a:solidFill>
+                      <a:prstDash val="solid"/>
+                      <a:round/>
+                      <a:headEnd len="sm" w="sm" type="none"/>
+                      <a:tailEnd len="sm" w="sm" type="none"/>
+                    </a:lnT>
+                    <a:lnB cap="flat" cmpd="sng" w="9525">
+                      <a:solidFill>
+                        <a:schemeClr val="dk1"/>
+                      </a:solidFill>
+                      <a:prstDash val="solid"/>
+                      <a:round/>
+                      <a:headEnd len="sm" w="sm" type="none"/>
+                      <a:tailEnd len="sm" w="sm" type="none"/>
+                    </a:lnB>
+                  </a:tcPr>
+                </a:tc>
+                <a:tc>
+                  <a:txBody>
+                    <a:bodyPr/>
+                    <a:lstStyle/>
+                    <a:p>
+                      <a:pPr indent="0" lvl="0" marL="0" rtl="0" algn="l">
+                        <a:spcBef>
+                          <a:spcPts val="0"/>
+                        </a:spcBef>
+                        <a:spcAft>
+                          <a:spcPts val="0"/>
+                        </a:spcAft>
+                        <a:buNone/>
+                      </a:pPr>
+                      <a:r>
+                        <a:rPr lang="en" sz="1000">
+                          <a:solidFill>
+                            <a:srgbClr val="1F5FBF"/>
+                          </a:solidFill>
+                        </a:rPr>
+                        <a:t>137%</a:t>
+                      </a:r>
+                      <a:endParaRPr sz="1000"/>
+                    </a:p>
+                  </a:txBody>
+                  <a:tcPr marT="91425" marB="91425" marR="91425" marL="91425">
+                    <a:lnL cap="flat" cmpd="sng" w="9525">
+                      <a:solidFill>
+                        <a:schemeClr val="dk1"/>
+                      </a:solidFill>
+                      <a:prstDash val="solid"/>
+                      <a:round/>
+                      <a:headEnd len="sm" w="sm" type="none"/>
+                      <a:tailEnd len="sm" w="sm" type="none"/>
+                    </a:lnL>
+                    <a:lnR cap="flat" cmpd="sng" w="9525">
+                      <a:solidFill>
+                        <a:schemeClr val="dk1"/>
+                      </a:solidFill>
+                      <a:prstDash val="solid"/>
+                      <a:round/>
+                      <a:headEnd len="sm" w="sm" type="none"/>
+                      <a:tailEnd len="sm" w="sm" type="none"/>
+                    </a:lnR>
+                    <a:lnT cap="flat" cmpd="sng" w="9525">
+                      <a:solidFill>
+                        <a:schemeClr val="dk1"/>
+                      </a:solidFill>
+                      <a:prstDash val="solid"/>
+                      <a:round/>
+                      <a:headEnd len="sm" w="sm" type="none"/>
+                      <a:tailEnd len="sm" w="sm" type="none"/>
+                    </a:lnT>
+                    <a:lnB cap="flat" cmpd="sng" w="9525">
+                      <a:solidFill>
+                        <a:schemeClr val="dk1"/>
+                      </a:solidFill>
+                      <a:prstDash val="solid"/>
+                      <a:round/>
+                      <a:headEnd len="sm" w="sm" type="none"/>
+                      <a:tailEnd len="sm" w="sm" type="none"/>
+                    </a:lnB>
+                  </a:tcPr>
+                </a:tc>
+                <a:tc>
+                  <a:txBody>
+                    <a:bodyPr/>
+                    <a:lstStyle/>
+                    <a:p>
+                      <a:pPr indent="0" lvl="0" marL="0" rtl="0" algn="l">
+                        <a:spcBef>
+                          <a:spcPts val="0"/>
+                        </a:spcBef>
+                        <a:spcAft>
+                          <a:spcPts val="0"/>
+                        </a:spcAft>
+                        <a:buNone/>
+                      </a:pPr>
+                      <a:r>
+                        <a:rPr lang="en" sz="1000">
+                          <a:solidFill>
+                            <a:srgbClr val="1F5FBF"/>
+                          </a:solidFill>
+                        </a:rPr>
+                        <a:t>16%</a:t>
+                      </a:r>
+                      <a:endParaRPr sz="1000"/>
+                    </a:p>
+                  </a:txBody>
+                  <a:tcPr marT="91425" marB="91425" marR="91425" marL="91425">
+                    <a:lnL cap="flat" cmpd="sng" w="9525">
+                      <a:solidFill>
+                        <a:schemeClr val="dk1"/>
+                      </a:solidFill>
+                      <a:prstDash val="solid"/>
+                      <a:round/>
+                      <a:headEnd len="sm" w="sm" type="none"/>
+                      <a:tailEnd len="sm" w="sm" type="none"/>
+                    </a:lnL>
+                    <a:lnR cap="flat" cmpd="sng" w="9525">
+                      <a:solidFill>
+                        <a:schemeClr val="dk1"/>
+                      </a:solidFill>
+                      <a:prstDash val="solid"/>
+                      <a:round/>
+                      <a:headEnd len="sm" w="sm" type="none"/>
+                      <a:tailEnd len="sm" w="sm" type="none"/>
+                    </a:lnR>
+                    <a:lnT cap="flat" cmpd="sng" w="9525">
+                      <a:solidFill>
+                        <a:schemeClr val="dk1"/>
+                      </a:solidFill>
+                      <a:prstDash val="solid"/>
+                      <a:round/>
+                      <a:headEnd len="sm" w="sm" type="none"/>
+                      <a:tailEnd len="sm" w="sm" type="none"/>
+                    </a:lnT>
+                    <a:lnB cap="flat" cmpd="sng" w="9525">
+                      <a:solidFill>
+                        <a:schemeClr val="dk1"/>
+                      </a:solidFill>
+                      <a:prstDash val="solid"/>
+                      <a:round/>
+                      <a:headEnd len="sm" w="sm" type="none"/>
+                      <a:tailEnd len="sm" w="sm" type="none"/>
+                    </a:lnB>
+                  </a:tcPr>
+                </a:tc>
+                <a:tc>
+                  <a:txBody>
+                    <a:bodyPr/>
+                    <a:lstStyle/>
+                    <a:p>
+                      <a:pPr indent="0" lvl="0" marL="0" rtl="0" algn="l">
+                        <a:spcBef>
+                          <a:spcPts val="0"/>
+                        </a:spcBef>
+                        <a:spcAft>
+                          <a:spcPts val="0"/>
+                        </a:spcAft>
+                        <a:buNone/>
+                      </a:pPr>
+                      <a:r>
+                        <a:rPr lang="en" sz="1000">
+                          <a:solidFill>
+                            <a:srgbClr val="1F5FBF"/>
+                          </a:solidFill>
+                        </a:rPr>
+                        <a:t>13%</a:t>
                       </a:r>
                       <a:endParaRPr sz="1000"/>
                     </a:p>
@@ -10186,2089 +11393,24 @@
         </p:blipFill>
         <p:spPr>
           <a:xfrm>
-            <a:off x="5532120" y="2240280"/>
-            <a:ext cx="3291840" cy="2373310"/>
+            <a:off x="6080760" y="2450592"/>
+            <a:ext cx="2697480" cy="1944796"/>
           </a:xfrm>
           <a:prstGeom prst="rect">
             <a:avLst/>
           </a:prstGeom>
         </p:spPr>
       </p:pic>
-    </p:spTree>
-  </p:cSld>
-  <p:clrMapOvr>
-    <a:masterClrMapping/>
-  </p:clrMapOvr>
-</p:sld>
-</file>
-
-<file path=ppt/slides/slide2.xml><?xml version="1.0" encoding="utf-8"?>
-<p:sld xmlns:a="http://schemas.openxmlformats.org/drawingml/2006/main" xmlns:r="http://schemas.openxmlformats.org/officeDocument/2006/relationships" xmlns:mc="http://schemas.openxmlformats.org/markup-compatibility/2006" xmlns:mv="urn:schemas-microsoft-com:mac:vml" xmlns:p="http://schemas.openxmlformats.org/presentationml/2006/main" xmlns:c="http://schemas.openxmlformats.org/drawingml/2006/chart" xmlns:dgm="http://schemas.openxmlformats.org/drawingml/2006/diagram" xmlns:o="urn:schemas-microsoft-com:office:office" xmlns:v="urn:schemas-microsoft-com:vml" xmlns:pvml="urn:schemas-microsoft-com:office:powerpoint" xmlns:com="http://schemas.openxmlformats.org/drawingml/2006/compatibility" xmlns:p14="http://schemas.microsoft.com/office/powerpoint/2010/main" xmlns:p15="http://schemas.microsoft.com/office/powerpoint/2012/main" xmlns:ahyp="http://schemas.microsoft.com/office/drawing/2018/hyperlinkcolor">
-  <p:cSld>
-    <p:spTree>
-      <p:nvGrpSpPr>
-        <p:cNvPr id="76" name="Shape 76"/>
-        <p:cNvGrpSpPr/>
-        <p:nvPr/>
-      </p:nvGrpSpPr>
-      <p:grpSpPr>
-        <a:xfrm>
-          <a:off x="0" y="0"/>
-          <a:ext cx="0" cy="0"/>
-          <a:chOff x="0" y="0"/>
-          <a:chExt cx="0" cy="0"/>
-        </a:xfrm>
-      </p:grpSpPr>
       <p:sp>
         <p:nvSpPr>
-          <p:cNvPr id="77" name="Google Shape;77;p17"/>
-          <p:cNvSpPr txBox="1"/>
-          <p:nvPr>
-            <p:ph type="title"/>
-          </p:nvPr>
-        </p:nvSpPr>
-        <p:spPr>
-          <a:xfrm>
-            <a:off x="311700" y="293400"/>
-            <a:ext cx="8520600" cy="572700"/>
-          </a:xfrm>
-          <a:prstGeom prst="rect">
-            <a:avLst/>
-          </a:prstGeom>
-        </p:spPr>
-        <p:txBody>
-          <a:bodyPr anchorCtr="0" anchor="t" bIns="91425" lIns="91425" spcFirstLastPara="1" rIns="91425" wrap="square" tIns="91425">
-            <a:normAutofit fontScale="90000"/>
-          </a:bodyPr>
-          <a:lstStyle/>
-          <a:p>
-            <a:pPr indent="0" lvl="0" marL="0" rtl="0" algn="l">
-              <a:spcBef>
-                <a:spcPts val="0"/>
-              </a:spcBef>
-              <a:spcAft>
-                <a:spcPts val="0"/>
-              </a:spcAft>
-              <a:buNone/>
-            </a:pPr>
-            <a:r>
-              <a:rPr lang="en"/>
-              <a:t>Projection: 4K 5 s video on 64 GPUs</a:t>
-            </a:r>
-            <a:endParaRPr/>
-          </a:p>
-        </p:txBody>
-      </p:sp>
-      <p:sp>
-        <p:nvSpPr>
-          <p:cNvPr id="78" name="Google Shape;78;p17"/>
-          <p:cNvSpPr txBox="1"/>
-          <p:nvPr>
-            <p:ph idx="1" type="body"/>
-          </p:nvPr>
-        </p:nvSpPr>
-        <p:spPr>
-          <a:xfrm>
-            <a:off x="311700" y="955000"/>
-            <a:ext cx="8520600" cy="1143000"/>
-          </a:xfrm>
-          <a:prstGeom prst="rect">
-            <a:avLst/>
-          </a:prstGeom>
-        </p:spPr>
-        <p:txBody>
-          <a:bodyPr anchorCtr="0" anchor="t" bIns="91425" lIns="91425" spcFirstLastPara="1" rIns="91425" wrap="square" tIns="91425">
-            <a:normAutofit/>
-          </a:bodyPr>
-          <a:lstStyle/>
-          <a:p>
-            <a:pPr indent="-304800" lvl="0" marL="457200" rtl="0" algn="l">
-              <a:spcBef>
-                <a:spcPts val="0"/>
-              </a:spcBef>
-              <a:spcAft>
-                <a:spcPts val="0"/>
-              </a:spcAft>
-              <a:buClr>
-                <a:schemeClr val="dk1"/>
-              </a:buClr>
-              <a:buSzPts val="1200"/>
-              <a:buChar char="●"/>
-            </a:pPr>
-            <a:r>
-              <a:rPr lang="en" sz="1200">
-                <a:solidFill>
-                  <a:schemeClr val="dk1"/>
-                </a:solidFill>
-              </a:rPr>
-              <a:t>Ring attention at scale: model fitted to all measurements (median error &lt; 4%)</a:t>
-            </a:r>
-            <a:endParaRPr sz="1200">
-              <a:solidFill>
-                <a:schemeClr val="dk1"/>
-              </a:solidFill>
-            </a:endParaRPr>
-          </a:p>
-          <a:p>
-            <a:pPr indent="-304800" lvl="1" marL="914400" rtl="0" algn="l">
-              <a:spcBef>
-                <a:spcPts val="0"/>
-              </a:spcBef>
-              <a:spcAft>
-                <a:spcPts val="0"/>
-              </a:spcAft>
-              <a:buClr>
-                <a:schemeClr val="dk1"/>
-              </a:buClr>
-              <a:buSzPts val="1200"/>
-              <a:buChar char="○"/>
-            </a:pPr>
-            <a:r>
-              <a:rPr b="1" lang="en" sz="1200">
-                <a:solidFill>
-                  <a:schemeClr val="dk1"/>
-                </a:solidFill>
-              </a:rPr>
-              <a:t>Assumed links</a:t>
-            </a:r>
-            <a:r>
-              <a:rPr lang="en" sz="1200">
-                <a:solidFill>
-                  <a:schemeClr val="dk1"/>
-                </a:solidFill>
-              </a:rPr>
-              <a:t>: IB 20 / 31 GB/s per GPU, NVL72 0.9 TB/s, glass 4 TB/s; H200 compute</a:t>
-            </a:r>
-            <a:endParaRPr sz="1200">
-              <a:solidFill>
-                <a:schemeClr val="dk1"/>
-              </a:solidFill>
-            </a:endParaRPr>
-          </a:p>
-          <a:p>
-            <a:pPr indent="-304800" lvl="1" marL="914400" rtl="0" algn="l">
-              <a:spcBef>
-                <a:spcPts val="0"/>
-              </a:spcBef>
-              <a:spcAft>
-                <a:spcPts val="0"/>
-              </a:spcAft>
-              <a:buClr>
-                <a:schemeClr val="dk1"/>
-              </a:buClr>
-              <a:buSzPts val="1200"/>
-              <a:buChar char="○"/>
-            </a:pPr>
-            <a:r>
-              <a:rPr b="1" lang="en" sz="1200">
-                <a:solidFill>
-                  <a:schemeClr val="dk1"/>
-                </a:solidFill>
-              </a:rPr>
-              <a:t>Dense</a:t>
-            </a:r>
-            <a:r>
-              <a:rPr lang="en" sz="1200">
-                <a:solidFill>
-                  <a:schemeClr val="dk1"/>
-                </a:solidFill>
-              </a:rPr>
-              <a:t>: NVL72 ≈ glass; the leftover ~13% is fixed cost (SM contention, kernel splitting)</a:t>
-            </a:r>
-            <a:endParaRPr sz="1200">
-              <a:solidFill>
-                <a:schemeClr val="dk1"/>
-              </a:solidFill>
-            </a:endParaRPr>
-          </a:p>
-          <a:p>
-            <a:pPr indent="-304800" lvl="1" marL="914400" rtl="0" algn="l">
-              <a:spcBef>
-                <a:spcPts val="0"/>
-              </a:spcBef>
-              <a:spcAft>
-                <a:spcPts val="0"/>
-              </a:spcAft>
-              <a:buClr>
-                <a:schemeClr val="dk1"/>
-              </a:buClr>
-              <a:buSzPts val="1200"/>
-              <a:buChar char="○"/>
-            </a:pPr>
-            <a:r>
-              <a:rPr b="1" lang="en" sz="1200">
-                <a:solidFill>
-                  <a:schemeClr val="dk1"/>
-                </a:solidFill>
-              </a:rPr>
-              <a:t>Causal + sparse</a:t>
-            </a:r>
-            <a:r>
-              <a:rPr lang="en" sz="1200">
-                <a:solidFill>
-                  <a:schemeClr val="dk1"/>
-                </a:solidFill>
-              </a:rPr>
-              <a:t>: glass 21% vs NVL72 37%; less compute per byte sent, bandwidth matters</a:t>
-            </a:r>
-            <a:endParaRPr sz="1200">
-              <a:solidFill>
-                <a:schemeClr val="dk1"/>
-              </a:solidFill>
-            </a:endParaRPr>
-          </a:p>
-        </p:txBody>
-      </p:sp>
-      <p:graphicFrame>
-        <p:nvGraphicFramePr>
-          <p:cNvPr id="80" name="Google Shape;80;p17"/>
-          <p:cNvGraphicFramePr/>
-          <p:nvPr/>
-        </p:nvGraphicFramePr>
-        <p:xfrm>
-          <a:off x="411480" y="2103120"/>
-          <a:ext cx="8275320" cy="1885500"/>
-        </p:xfrm>
-        <a:graphic>
-          <a:graphicData uri="http://schemas.openxmlformats.org/drawingml/2006/table">
-            <a:tbl>
-              <a:tblPr>
-                <a:noFill/>
-                <a:tableStyleId>{560E7119-B5C1-419B-856C-2FA07D2E47C7}</a:tableStyleId>
-              </a:tblPr>
-              <a:tblGrid>
-                <a:gridCol w="2606040"/>
-                <a:gridCol w="1417320"/>
-                <a:gridCol w="1417320"/>
-                <a:gridCol w="1417320"/>
-                <a:gridCol w="1417320"/>
-              </a:tblGrid>
-              <a:tr h="314250">
-                <a:tc>
-                  <a:txBody>
-                    <a:bodyPr/>
-                    <a:lstStyle/>
-                    <a:p>
-                      <a:pPr indent="0" lvl="0" marL="0" rtl="0" algn="l">
-                        <a:spcBef>
-                          <a:spcPts val="0"/>
-                        </a:spcBef>
-                        <a:spcAft>
-                          <a:spcPts val="0"/>
-                        </a:spcAft>
-                        <a:buNone/>
-                      </a:pPr>
-                      <a:r>
-                        <a:rPr lang="en" sz="1000"/>
-                        <a:t>Overhead (inference / training)</a:t>
-                      </a:r>
-                      <a:endParaRPr sz="1000"/>
-                    </a:p>
-                  </a:txBody>
-                  <a:tcPr marT="91425" marB="91425" marR="91425" marL="91425">
-                    <a:lnL cap="flat" cmpd="sng" w="9525">
-                      <a:solidFill>
-                        <a:schemeClr val="dk1"/>
-                      </a:solidFill>
-                      <a:prstDash val="solid"/>
-                      <a:round/>
-                      <a:headEnd len="sm" w="sm" type="none"/>
-                      <a:tailEnd len="sm" w="sm" type="none"/>
-                    </a:lnL>
-                    <a:lnR cap="flat" cmpd="sng" w="9525">
-                      <a:solidFill>
-                        <a:schemeClr val="dk1"/>
-                      </a:solidFill>
-                      <a:prstDash val="solid"/>
-                      <a:round/>
-                      <a:headEnd len="sm" w="sm" type="none"/>
-                      <a:tailEnd len="sm" w="sm" type="none"/>
-                    </a:lnR>
-                    <a:lnT cap="flat" cmpd="sng" w="9525">
-                      <a:solidFill>
-                        <a:schemeClr val="dk1"/>
-                      </a:solidFill>
-                      <a:prstDash val="solid"/>
-                      <a:round/>
-                      <a:headEnd len="sm" w="sm" type="none"/>
-                      <a:tailEnd len="sm" w="sm" type="none"/>
-                    </a:lnT>
-                    <a:lnB cap="flat" cmpd="sng" w="9525">
-                      <a:solidFill>
-                        <a:schemeClr val="dk1"/>
-                      </a:solidFill>
-                      <a:prstDash val="solid"/>
-                      <a:round/>
-                      <a:headEnd len="sm" w="sm" type="none"/>
-                      <a:tailEnd len="sm" w="sm" type="none"/>
-                    </a:lnB>
-                  </a:tcPr>
-                </a:tc>
-                <a:tc>
-                  <a:txBody>
-                    <a:bodyPr/>
-                    <a:lstStyle/>
-                    <a:p>
-                      <a:pPr indent="0" lvl="0" marL="0" rtl="0" algn="l">
-                        <a:spcBef>
-                          <a:spcPts val="0"/>
-                        </a:spcBef>
-                        <a:spcAft>
-                          <a:spcPts val="0"/>
-                        </a:spcAft>
-                        <a:buNone/>
-                      </a:pPr>
-                      <a:r>
-                        <a:rPr lang="en" sz="1000"/>
-                        <a:t>IB (20 GB/s)</a:t>
-                      </a:r>
-                      <a:endParaRPr sz="1000"/>
-                    </a:p>
-                  </a:txBody>
-                  <a:tcPr marT="91425" marB="91425" marR="91425" marL="91425">
-                    <a:lnL cap="flat" cmpd="sng" w="9525">
-                      <a:solidFill>
-                        <a:schemeClr val="dk1"/>
-                      </a:solidFill>
-                      <a:prstDash val="solid"/>
-                      <a:round/>
-                      <a:headEnd len="sm" w="sm" type="none"/>
-                      <a:tailEnd len="sm" w="sm" type="none"/>
-                    </a:lnL>
-                    <a:lnR cap="flat" cmpd="sng" w="9525">
-                      <a:solidFill>
-                        <a:schemeClr val="dk1"/>
-                      </a:solidFill>
-                      <a:prstDash val="solid"/>
-                      <a:round/>
-                      <a:headEnd len="sm" w="sm" type="none"/>
-                      <a:tailEnd len="sm" w="sm" type="none"/>
-                    </a:lnR>
-                    <a:lnT cap="flat" cmpd="sng" w="9525">
-                      <a:solidFill>
-                        <a:schemeClr val="dk1"/>
-                      </a:solidFill>
-                      <a:prstDash val="solid"/>
-                      <a:round/>
-                      <a:headEnd len="sm" w="sm" type="none"/>
-                      <a:tailEnd len="sm" w="sm" type="none"/>
-                    </a:lnT>
-                    <a:lnB cap="flat" cmpd="sng" w="9525">
-                      <a:solidFill>
-                        <a:schemeClr val="dk1"/>
-                      </a:solidFill>
-                      <a:prstDash val="solid"/>
-                      <a:round/>
-                      <a:headEnd len="sm" w="sm" type="none"/>
-                      <a:tailEnd len="sm" w="sm" type="none"/>
-                    </a:lnB>
-                  </a:tcPr>
-                </a:tc>
-                <a:tc>
-                  <a:txBody>
-                    <a:bodyPr/>
-                    <a:lstStyle/>
-                    <a:p>
-                      <a:pPr indent="0" lvl="0" marL="0" rtl="0" algn="l">
-                        <a:spcBef>
-                          <a:spcPts val="0"/>
-                        </a:spcBef>
-                        <a:spcAft>
-                          <a:spcPts val="0"/>
-                        </a:spcAft>
-                        <a:buNone/>
-                      </a:pPr>
-                      <a:r>
-                        <a:rPr lang="en" sz="1000"/>
-                        <a:t>IB, 4 ch (31 GB/s)</a:t>
-                      </a:r>
-                      <a:endParaRPr sz="1000"/>
-                    </a:p>
-                  </a:txBody>
-                  <a:tcPr marT="91425" marB="91425" marR="91425" marL="91425">
-                    <a:lnL cap="flat" cmpd="sng" w="9525">
-                      <a:solidFill>
-                        <a:schemeClr val="dk1"/>
-                      </a:solidFill>
-                      <a:prstDash val="solid"/>
-                      <a:round/>
-                      <a:headEnd len="sm" w="sm" type="none"/>
-                      <a:tailEnd len="sm" w="sm" type="none"/>
-                    </a:lnL>
-                    <a:lnR cap="flat" cmpd="sng" w="9525">
-                      <a:solidFill>
-                        <a:schemeClr val="dk1"/>
-                      </a:solidFill>
-                      <a:prstDash val="solid"/>
-                      <a:round/>
-                      <a:headEnd len="sm" w="sm" type="none"/>
-                      <a:tailEnd len="sm" w="sm" type="none"/>
-                    </a:lnR>
-                    <a:lnT cap="flat" cmpd="sng" w="9525">
-                      <a:solidFill>
-                        <a:schemeClr val="dk1"/>
-                      </a:solidFill>
-                      <a:prstDash val="solid"/>
-                      <a:round/>
-                      <a:headEnd len="sm" w="sm" type="none"/>
-                      <a:tailEnd len="sm" w="sm" type="none"/>
-                    </a:lnT>
-                    <a:lnB cap="flat" cmpd="sng" w="9525">
-                      <a:solidFill>
-                        <a:schemeClr val="dk1"/>
-                      </a:solidFill>
-                      <a:prstDash val="solid"/>
-                      <a:round/>
-                      <a:headEnd len="sm" w="sm" type="none"/>
-                      <a:tailEnd len="sm" w="sm" type="none"/>
-                    </a:lnB>
-                  </a:tcPr>
-                </a:tc>
-                <a:tc>
-                  <a:txBody>
-                    <a:bodyPr/>
-                    <a:lstStyle/>
-                    <a:p>
-                      <a:pPr indent="0" lvl="0" marL="0" rtl="0" algn="l">
-                        <a:spcBef>
-                          <a:spcPts val="0"/>
-                        </a:spcBef>
-                        <a:spcAft>
-                          <a:spcPts val="0"/>
-                        </a:spcAft>
-                        <a:buNone/>
-                      </a:pPr>
-                      <a:r>
-                        <a:rPr lang="en" sz="1000"/>
-                        <a:t>NVL72 (0.9 TB/s)</a:t>
-                      </a:r>
-                      <a:endParaRPr sz="1000"/>
-                    </a:p>
-                  </a:txBody>
-                  <a:tcPr marT="91425" marB="91425" marR="91425" marL="91425">
-                    <a:lnL cap="flat" cmpd="sng" w="9525">
-                      <a:solidFill>
-                        <a:schemeClr val="dk1"/>
-                      </a:solidFill>
-                      <a:prstDash val="solid"/>
-                      <a:round/>
-                      <a:headEnd len="sm" w="sm" type="none"/>
-                      <a:tailEnd len="sm" w="sm" type="none"/>
-                    </a:lnL>
-                    <a:lnR cap="flat" cmpd="sng" w="9525">
-                      <a:solidFill>
-                        <a:schemeClr val="dk1"/>
-                      </a:solidFill>
-                      <a:prstDash val="solid"/>
-                      <a:round/>
-                      <a:headEnd len="sm" w="sm" type="none"/>
-                      <a:tailEnd len="sm" w="sm" type="none"/>
-                    </a:lnR>
-                    <a:lnT cap="flat" cmpd="sng" w="9525">
-                      <a:solidFill>
-                        <a:schemeClr val="dk1"/>
-                      </a:solidFill>
-                      <a:prstDash val="solid"/>
-                      <a:round/>
-                      <a:headEnd len="sm" w="sm" type="none"/>
-                      <a:tailEnd len="sm" w="sm" type="none"/>
-                    </a:lnT>
-                    <a:lnB cap="flat" cmpd="sng" w="9525">
-                      <a:solidFill>
-                        <a:schemeClr val="dk1"/>
-                      </a:solidFill>
-                      <a:prstDash val="solid"/>
-                      <a:round/>
-                      <a:headEnd len="sm" w="sm" type="none"/>
-                      <a:tailEnd len="sm" w="sm" type="none"/>
-                    </a:lnB>
-                  </a:tcPr>
-                </a:tc>
-                <a:tc>
-                  <a:txBody>
-                    <a:bodyPr/>
-                    <a:lstStyle/>
-                    <a:p>
-                      <a:pPr indent="0" lvl="0" marL="0" rtl="0" algn="l">
-                        <a:spcBef>
-                          <a:spcPts val="0"/>
-                        </a:spcBef>
-                        <a:spcAft>
-                          <a:spcPts val="0"/>
-                        </a:spcAft>
-                        <a:buNone/>
-                      </a:pPr>
-                      <a:r>
-                        <a:rPr lang="en" sz="1000"/>
-                        <a:t>Glass (4 TB/s)</a:t>
-                      </a:r>
-                      <a:endParaRPr sz="1000"/>
-                    </a:p>
-                  </a:txBody>
-                  <a:tcPr marT="91425" marB="91425" marR="91425" marL="91425">
-                    <a:lnL cap="flat" cmpd="sng" w="9525">
-                      <a:solidFill>
-                        <a:schemeClr val="dk1"/>
-                      </a:solidFill>
-                      <a:prstDash val="solid"/>
-                      <a:round/>
-                      <a:headEnd len="sm" w="sm" type="none"/>
-                      <a:tailEnd len="sm" w="sm" type="none"/>
-                    </a:lnL>
-                    <a:lnR cap="flat" cmpd="sng" w="9525">
-                      <a:solidFill>
-                        <a:schemeClr val="dk1"/>
-                      </a:solidFill>
-                      <a:prstDash val="solid"/>
-                      <a:round/>
-                      <a:headEnd len="sm" w="sm" type="none"/>
-                      <a:tailEnd len="sm" w="sm" type="none"/>
-                    </a:lnR>
-                    <a:lnT cap="flat" cmpd="sng" w="9525">
-                      <a:solidFill>
-                        <a:schemeClr val="dk1"/>
-                      </a:solidFill>
-                      <a:prstDash val="solid"/>
-                      <a:round/>
-                      <a:headEnd len="sm" w="sm" type="none"/>
-                      <a:tailEnd len="sm" w="sm" type="none"/>
-                    </a:lnT>
-                    <a:lnB cap="flat" cmpd="sng" w="9525">
-                      <a:solidFill>
-                        <a:schemeClr val="dk1"/>
-                      </a:solidFill>
-                      <a:prstDash val="solid"/>
-                      <a:round/>
-                      <a:headEnd len="sm" w="sm" type="none"/>
-                      <a:tailEnd len="sm" w="sm" type="none"/>
-                    </a:lnB>
-                  </a:tcPr>
-                </a:tc>
-              </a:tr>
-              <a:tr h="314250">
-                <a:tc>
-                  <a:txBody>
-                    <a:bodyPr/>
-                    <a:lstStyle/>
-                    <a:p>
-                      <a:pPr indent="0" lvl="0" marL="0" rtl="0" algn="l">
-                        <a:spcBef>
-                          <a:spcPts val="0"/>
-                        </a:spcBef>
-                        <a:spcAft>
-                          <a:spcPts val="0"/>
-                        </a:spcAft>
-                        <a:buNone/>
-                      </a:pPr>
-                      <a:r>
-                        <a:rPr lang="en" sz="1000"/>
-                        <a:t>Ring 64, bidirectional, dense</a:t>
-                      </a:r>
-                      <a:endParaRPr sz="1000"/>
-                    </a:p>
-                  </a:txBody>
-                  <a:tcPr marT="91425" marB="91425" marR="91425" marL="91425">
-                    <a:lnL cap="flat" cmpd="sng" w="9525">
-                      <a:solidFill>
-                        <a:schemeClr val="dk1"/>
-                      </a:solidFill>
-                      <a:prstDash val="solid"/>
-                      <a:round/>
-                      <a:headEnd len="sm" w="sm" type="none"/>
-                      <a:tailEnd len="sm" w="sm" type="none"/>
-                    </a:lnL>
-                    <a:lnR cap="flat" cmpd="sng" w="9525">
-                      <a:solidFill>
-                        <a:schemeClr val="dk1"/>
-                      </a:solidFill>
-                      <a:prstDash val="solid"/>
-                      <a:round/>
-                      <a:headEnd len="sm" w="sm" type="none"/>
-                      <a:tailEnd len="sm" w="sm" type="none"/>
-                    </a:lnR>
-                    <a:lnT cap="flat" cmpd="sng" w="9525">
-                      <a:solidFill>
-                        <a:schemeClr val="dk1"/>
-                      </a:solidFill>
-                      <a:prstDash val="solid"/>
-                      <a:round/>
-                      <a:headEnd len="sm" w="sm" type="none"/>
-                      <a:tailEnd len="sm" w="sm" type="none"/>
-                    </a:lnT>
-                    <a:lnB cap="flat" cmpd="sng" w="9525">
-                      <a:solidFill>
-                        <a:schemeClr val="dk1"/>
-                      </a:solidFill>
-                      <a:prstDash val="solid"/>
-                      <a:round/>
-                      <a:headEnd len="sm" w="sm" type="none"/>
-                      <a:tailEnd len="sm" w="sm" type="none"/>
-                    </a:lnB>
-                  </a:tcPr>
-                </a:tc>
-                <a:tc>
-                  <a:txBody>
-                    <a:bodyPr/>
-                    <a:lstStyle/>
-                    <a:p>
-                      <a:pPr indent="0" lvl="0" marL="0" rtl="0" algn="l">
-                        <a:spcBef>
-                          <a:spcPts val="0"/>
-                        </a:spcBef>
-                        <a:spcAft>
-                          <a:spcPts val="0"/>
-                        </a:spcAft>
-                        <a:buNone/>
-                      </a:pPr>
-                      <a:r>
-                        <a:rPr lang="en" sz="1000"/>
-                        <a:t>145% / 113%</a:t>
-                      </a:r>
-                      <a:endParaRPr sz="1000"/>
-                    </a:p>
-                  </a:txBody>
-                  <a:tcPr marT="91425" marB="91425" marR="91425" marL="91425">
-                    <a:lnL cap="flat" cmpd="sng" w="9525">
-                      <a:solidFill>
-                        <a:schemeClr val="dk1"/>
-                      </a:solidFill>
-                      <a:prstDash val="solid"/>
-                      <a:round/>
-                      <a:headEnd len="sm" w="sm" type="none"/>
-                      <a:tailEnd len="sm" w="sm" type="none"/>
-                    </a:lnL>
-                    <a:lnR cap="flat" cmpd="sng" w="9525">
-                      <a:solidFill>
-                        <a:schemeClr val="dk1"/>
-                      </a:solidFill>
-                      <a:prstDash val="solid"/>
-                      <a:round/>
-                      <a:headEnd len="sm" w="sm" type="none"/>
-                      <a:tailEnd len="sm" w="sm" type="none"/>
-                    </a:lnR>
-                    <a:lnT cap="flat" cmpd="sng" w="9525">
-                      <a:solidFill>
-                        <a:schemeClr val="dk1"/>
-                      </a:solidFill>
-                      <a:prstDash val="solid"/>
-                      <a:round/>
-                      <a:headEnd len="sm" w="sm" type="none"/>
-                      <a:tailEnd len="sm" w="sm" type="none"/>
-                    </a:lnT>
-                    <a:lnB cap="flat" cmpd="sng" w="9525">
-                      <a:solidFill>
-                        <a:schemeClr val="dk1"/>
-                      </a:solidFill>
-                      <a:prstDash val="solid"/>
-                      <a:round/>
-                      <a:headEnd len="sm" w="sm" type="none"/>
-                      <a:tailEnd len="sm" w="sm" type="none"/>
-                    </a:lnB>
-                  </a:tcPr>
-                </a:tc>
-                <a:tc>
-                  <a:txBody>
-                    <a:bodyPr/>
-                    <a:lstStyle/>
-                    <a:p>
-                      <a:pPr indent="0" lvl="0" marL="0" rtl="0" algn="l">
-                        <a:spcBef>
-                          <a:spcPts val="0"/>
-                        </a:spcBef>
-                        <a:spcAft>
-                          <a:spcPts val="0"/>
-                        </a:spcAft>
-                        <a:buNone/>
-                      </a:pPr>
-                      <a:r>
-                        <a:rPr lang="en" sz="1000"/>
-                        <a:t>80% / 61%</a:t>
-                      </a:r>
-                      <a:endParaRPr sz="1000"/>
-                    </a:p>
-                  </a:txBody>
-                  <a:tcPr marT="91425" marB="91425" marR="91425" marL="91425">
-                    <a:lnL cap="flat" cmpd="sng" w="9525">
-                      <a:solidFill>
-                        <a:schemeClr val="dk1"/>
-                      </a:solidFill>
-                      <a:prstDash val="solid"/>
-                      <a:round/>
-                      <a:headEnd len="sm" w="sm" type="none"/>
-                      <a:tailEnd len="sm" w="sm" type="none"/>
-                    </a:lnL>
-                    <a:lnR cap="flat" cmpd="sng" w="9525">
-                      <a:solidFill>
-                        <a:schemeClr val="dk1"/>
-                      </a:solidFill>
-                      <a:prstDash val="solid"/>
-                      <a:round/>
-                      <a:headEnd len="sm" w="sm" type="none"/>
-                      <a:tailEnd len="sm" w="sm" type="none"/>
-                    </a:lnR>
-                    <a:lnT cap="flat" cmpd="sng" w="9525">
-                      <a:solidFill>
-                        <a:schemeClr val="dk1"/>
-                      </a:solidFill>
-                      <a:prstDash val="solid"/>
-                      <a:round/>
-                      <a:headEnd len="sm" w="sm" type="none"/>
-                      <a:tailEnd len="sm" w="sm" type="none"/>
-                    </a:lnT>
-                    <a:lnB cap="flat" cmpd="sng" w="9525">
-                      <a:solidFill>
-                        <a:schemeClr val="dk1"/>
-                      </a:solidFill>
-                      <a:prstDash val="solid"/>
-                      <a:round/>
-                      <a:headEnd len="sm" w="sm" type="none"/>
-                      <a:tailEnd len="sm" w="sm" type="none"/>
-                    </a:lnB>
-                  </a:tcPr>
-                </a:tc>
-                <a:tc>
-                  <a:txBody>
-                    <a:bodyPr/>
-                    <a:lstStyle/>
-                    <a:p>
-                      <a:pPr indent="0" lvl="0" marL="0" rtl="0" algn="l">
-                        <a:spcBef>
-                          <a:spcPts val="0"/>
-                        </a:spcBef>
-                        <a:spcAft>
-                          <a:spcPts val="0"/>
-                        </a:spcAft>
-                        <a:buNone/>
-                      </a:pPr>
-                      <a:r>
-                        <a:rPr lang="en" sz="1000"/>
-                        <a:t>17% / 14%</a:t>
-                      </a:r>
-                      <a:endParaRPr sz="1000"/>
-                    </a:p>
-                  </a:txBody>
-                  <a:tcPr marT="91425" marB="91425" marR="91425" marL="91425">
-                    <a:lnL cap="flat" cmpd="sng" w="9525">
-                      <a:solidFill>
-                        <a:schemeClr val="dk1"/>
-                      </a:solidFill>
-                      <a:prstDash val="solid"/>
-                      <a:round/>
-                      <a:headEnd len="sm" w="sm" type="none"/>
-                      <a:tailEnd len="sm" w="sm" type="none"/>
-                    </a:lnL>
-                    <a:lnR cap="flat" cmpd="sng" w="9525">
-                      <a:solidFill>
-                        <a:schemeClr val="dk1"/>
-                      </a:solidFill>
-                      <a:prstDash val="solid"/>
-                      <a:round/>
-                      <a:headEnd len="sm" w="sm" type="none"/>
-                      <a:tailEnd len="sm" w="sm" type="none"/>
-                    </a:lnR>
-                    <a:lnT cap="flat" cmpd="sng" w="9525">
-                      <a:solidFill>
-                        <a:schemeClr val="dk1"/>
-                      </a:solidFill>
-                      <a:prstDash val="solid"/>
-                      <a:round/>
-                      <a:headEnd len="sm" w="sm" type="none"/>
-                      <a:tailEnd len="sm" w="sm" type="none"/>
-                    </a:lnT>
-                    <a:lnB cap="flat" cmpd="sng" w="9525">
-                      <a:solidFill>
-                        <a:schemeClr val="dk1"/>
-                      </a:solidFill>
-                      <a:prstDash val="solid"/>
-                      <a:round/>
-                      <a:headEnd len="sm" w="sm" type="none"/>
-                      <a:tailEnd len="sm" w="sm" type="none"/>
-                    </a:lnB>
-                  </a:tcPr>
-                </a:tc>
-                <a:tc>
-                  <a:txBody>
-                    <a:bodyPr/>
-                    <a:lstStyle/>
-                    <a:p>
-                      <a:pPr indent="0" lvl="0" marL="0" rtl="0" algn="l">
-                        <a:spcBef>
-                          <a:spcPts val="0"/>
-                        </a:spcBef>
-                        <a:spcAft>
-                          <a:spcPts val="0"/>
-                        </a:spcAft>
-                        <a:buNone/>
-                      </a:pPr>
-                      <a:r>
-                        <a:rPr lang="en" sz="1000"/>
-                        <a:t>16% / 12%</a:t>
-                      </a:r>
-                      <a:endParaRPr sz="1000"/>
-                    </a:p>
-                  </a:txBody>
-                  <a:tcPr marT="91425" marB="91425" marR="91425" marL="91425">
-                    <a:lnL cap="flat" cmpd="sng" w="9525">
-                      <a:solidFill>
-                        <a:schemeClr val="dk1"/>
-                      </a:solidFill>
-                      <a:prstDash val="solid"/>
-                      <a:round/>
-                      <a:headEnd len="sm" w="sm" type="none"/>
-                      <a:tailEnd len="sm" w="sm" type="none"/>
-                    </a:lnL>
-                    <a:lnR cap="flat" cmpd="sng" w="9525">
-                      <a:solidFill>
-                        <a:schemeClr val="dk1"/>
-                      </a:solidFill>
-                      <a:prstDash val="solid"/>
-                      <a:round/>
-                      <a:headEnd len="sm" w="sm" type="none"/>
-                      <a:tailEnd len="sm" w="sm" type="none"/>
-                    </a:lnR>
-                    <a:lnT cap="flat" cmpd="sng" w="9525">
-                      <a:solidFill>
-                        <a:schemeClr val="dk1"/>
-                      </a:solidFill>
-                      <a:prstDash val="solid"/>
-                      <a:round/>
-                      <a:headEnd len="sm" w="sm" type="none"/>
-                      <a:tailEnd len="sm" w="sm" type="none"/>
-                    </a:lnT>
-                    <a:lnB cap="flat" cmpd="sng" w="9525">
-                      <a:solidFill>
-                        <a:schemeClr val="dk1"/>
-                      </a:solidFill>
-                      <a:prstDash val="solid"/>
-                      <a:round/>
-                      <a:headEnd len="sm" w="sm" type="none"/>
-                      <a:tailEnd len="sm" w="sm" type="none"/>
-                    </a:lnB>
-                  </a:tcPr>
-                </a:tc>
-              </a:tr>
-              <a:tr h="314250">
-                <a:tc>
-                  <a:txBody>
-                    <a:bodyPr/>
-                    <a:lstStyle/>
-                    <a:p>
-                      <a:pPr indent="0" lvl="0" marL="0" rtl="0" algn="l">
-                        <a:spcBef>
-                          <a:spcPts val="0"/>
-                        </a:spcBef>
-                        <a:spcAft>
-                          <a:spcPts val="0"/>
-                        </a:spcAft>
-                        <a:buNone/>
-                      </a:pPr>
-                      <a:r>
-                        <a:rPr lang="en" sz="1000"/>
-                        <a:t>Ring 64, causal, dense</a:t>
-                      </a:r>
-                      <a:endParaRPr sz="1000"/>
-                    </a:p>
-                  </a:txBody>
-                  <a:tcPr marT="91425" marB="91425" marR="91425" marL="91425">
-                    <a:lnL cap="flat" cmpd="sng" w="9525">
-                      <a:solidFill>
-                        <a:schemeClr val="dk1"/>
-                      </a:solidFill>
-                      <a:prstDash val="solid"/>
-                      <a:round/>
-                      <a:headEnd len="sm" w="sm" type="none"/>
-                      <a:tailEnd len="sm" w="sm" type="none"/>
-                    </a:lnL>
-                    <a:lnR cap="flat" cmpd="sng" w="9525">
-                      <a:solidFill>
-                        <a:schemeClr val="dk1"/>
-                      </a:solidFill>
-                      <a:prstDash val="solid"/>
-                      <a:round/>
-                      <a:headEnd len="sm" w="sm" type="none"/>
-                      <a:tailEnd len="sm" w="sm" type="none"/>
-                    </a:lnR>
-                    <a:lnT cap="flat" cmpd="sng" w="9525">
-                      <a:solidFill>
-                        <a:schemeClr val="dk1"/>
-                      </a:solidFill>
-                      <a:prstDash val="solid"/>
-                      <a:round/>
-                      <a:headEnd len="sm" w="sm" type="none"/>
-                      <a:tailEnd len="sm" w="sm" type="none"/>
-                    </a:lnT>
-                    <a:lnB cap="flat" cmpd="sng" w="9525">
-                      <a:solidFill>
-                        <a:schemeClr val="dk1"/>
-                      </a:solidFill>
-                      <a:prstDash val="solid"/>
-                      <a:round/>
-                      <a:headEnd len="sm" w="sm" type="none"/>
-                      <a:tailEnd len="sm" w="sm" type="none"/>
-                    </a:lnB>
-                  </a:tcPr>
-                </a:tc>
-                <a:tc>
-                  <a:txBody>
-                    <a:bodyPr/>
-                    <a:lstStyle/>
-                    <a:p>
-                      <a:pPr indent="0" lvl="0" marL="0" rtl="0" algn="l">
-                        <a:spcBef>
-                          <a:spcPts val="0"/>
-                        </a:spcBef>
-                        <a:spcAft>
-                          <a:spcPts val="0"/>
-                        </a:spcAft>
-                        <a:buNone/>
-                      </a:pPr>
-                      <a:r>
-                        <a:rPr lang="en" sz="1000"/>
-                        <a:t>328% / 303%</a:t>
-                      </a:r>
-                      <a:endParaRPr sz="1000"/>
-                    </a:p>
-                  </a:txBody>
-                  <a:tcPr marT="91425" marB="91425" marR="91425" marL="91425">
-                    <a:lnL cap="flat" cmpd="sng" w="9525">
-                      <a:solidFill>
-                        <a:schemeClr val="dk1"/>
-                      </a:solidFill>
-                      <a:prstDash val="solid"/>
-                      <a:round/>
-                      <a:headEnd len="sm" w="sm" type="none"/>
-                      <a:tailEnd len="sm" w="sm" type="none"/>
-                    </a:lnL>
-                    <a:lnR cap="flat" cmpd="sng" w="9525">
-                      <a:solidFill>
-                        <a:schemeClr val="dk1"/>
-                      </a:solidFill>
-                      <a:prstDash val="solid"/>
-                      <a:round/>
-                      <a:headEnd len="sm" w="sm" type="none"/>
-                      <a:tailEnd len="sm" w="sm" type="none"/>
-                    </a:lnR>
-                    <a:lnT cap="flat" cmpd="sng" w="9525">
-                      <a:solidFill>
-                        <a:schemeClr val="dk1"/>
-                      </a:solidFill>
-                      <a:prstDash val="solid"/>
-                      <a:round/>
-                      <a:headEnd len="sm" w="sm" type="none"/>
-                      <a:tailEnd len="sm" w="sm" type="none"/>
-                    </a:lnT>
-                    <a:lnB cap="flat" cmpd="sng" w="9525">
-                      <a:solidFill>
-                        <a:schemeClr val="dk1"/>
-                      </a:solidFill>
-                      <a:prstDash val="solid"/>
-                      <a:round/>
-                      <a:headEnd len="sm" w="sm" type="none"/>
-                      <a:tailEnd len="sm" w="sm" type="none"/>
-                    </a:lnB>
-                  </a:tcPr>
-                </a:tc>
-                <a:tc>
-                  <a:txBody>
-                    <a:bodyPr/>
-                    <a:lstStyle/>
-                    <a:p>
-                      <a:pPr indent="0" lvl="0" marL="0" rtl="0" algn="l">
-                        <a:spcBef>
-                          <a:spcPts val="0"/>
-                        </a:spcBef>
-                        <a:spcAft>
-                          <a:spcPts val="0"/>
-                        </a:spcAft>
-                        <a:buNone/>
-                      </a:pPr>
-                      <a:r>
-                        <a:rPr lang="en" sz="1000"/>
-                        <a:t>197% / 166%</a:t>
-                      </a:r>
-                      <a:endParaRPr sz="1000"/>
-                    </a:p>
-                  </a:txBody>
-                  <a:tcPr marT="91425" marB="91425" marR="91425" marL="91425">
-                    <a:lnL cap="flat" cmpd="sng" w="9525">
-                      <a:solidFill>
-                        <a:schemeClr val="dk1"/>
-                      </a:solidFill>
-                      <a:prstDash val="solid"/>
-                      <a:round/>
-                      <a:headEnd len="sm" w="sm" type="none"/>
-                      <a:tailEnd len="sm" w="sm" type="none"/>
-                    </a:lnL>
-                    <a:lnR cap="flat" cmpd="sng" w="9525">
-                      <a:solidFill>
-                        <a:schemeClr val="dk1"/>
-                      </a:solidFill>
-                      <a:prstDash val="solid"/>
-                      <a:round/>
-                      <a:headEnd len="sm" w="sm" type="none"/>
-                      <a:tailEnd len="sm" w="sm" type="none"/>
-                    </a:lnR>
-                    <a:lnT cap="flat" cmpd="sng" w="9525">
-                      <a:solidFill>
-                        <a:schemeClr val="dk1"/>
-                      </a:solidFill>
-                      <a:prstDash val="solid"/>
-                      <a:round/>
-                      <a:headEnd len="sm" w="sm" type="none"/>
-                      <a:tailEnd len="sm" w="sm" type="none"/>
-                    </a:lnT>
-                    <a:lnB cap="flat" cmpd="sng" w="9525">
-                      <a:solidFill>
-                        <a:schemeClr val="dk1"/>
-                      </a:solidFill>
-                      <a:prstDash val="solid"/>
-                      <a:round/>
-                      <a:headEnd len="sm" w="sm" type="none"/>
-                      <a:tailEnd len="sm" w="sm" type="none"/>
-                    </a:lnB>
-                  </a:tcPr>
-                </a:tc>
-                <a:tc>
-                  <a:txBody>
-                    <a:bodyPr/>
-                    <a:lstStyle/>
-                    <a:p>
-                      <a:pPr indent="0" lvl="0" marL="0" rtl="0" algn="l">
-                        <a:spcBef>
-                          <a:spcPts val="0"/>
-                        </a:spcBef>
-                        <a:spcAft>
-                          <a:spcPts val="0"/>
-                        </a:spcAft>
-                        <a:buNone/>
-                      </a:pPr>
-                      <a:r>
-                        <a:rPr lang="en" sz="1000"/>
-                        <a:t>19% / 16%</a:t>
-                      </a:r>
-                      <a:endParaRPr sz="1000"/>
-                    </a:p>
-                  </a:txBody>
-                  <a:tcPr marT="91425" marB="91425" marR="91425" marL="91425">
-                    <a:lnL cap="flat" cmpd="sng" w="9525">
-                      <a:solidFill>
-                        <a:schemeClr val="dk1"/>
-                      </a:solidFill>
-                      <a:prstDash val="solid"/>
-                      <a:round/>
-                      <a:headEnd len="sm" w="sm" type="none"/>
-                      <a:tailEnd len="sm" w="sm" type="none"/>
-                    </a:lnL>
-                    <a:lnR cap="flat" cmpd="sng" w="9525">
-                      <a:solidFill>
-                        <a:schemeClr val="dk1"/>
-                      </a:solidFill>
-                      <a:prstDash val="solid"/>
-                      <a:round/>
-                      <a:headEnd len="sm" w="sm" type="none"/>
-                      <a:tailEnd len="sm" w="sm" type="none"/>
-                    </a:lnR>
-                    <a:lnT cap="flat" cmpd="sng" w="9525">
-                      <a:solidFill>
-                        <a:schemeClr val="dk1"/>
-                      </a:solidFill>
-                      <a:prstDash val="solid"/>
-                      <a:round/>
-                      <a:headEnd len="sm" w="sm" type="none"/>
-                      <a:tailEnd len="sm" w="sm" type="none"/>
-                    </a:lnT>
-                    <a:lnB cap="flat" cmpd="sng" w="9525">
-                      <a:solidFill>
-                        <a:schemeClr val="dk1"/>
-                      </a:solidFill>
-                      <a:prstDash val="solid"/>
-                      <a:round/>
-                      <a:headEnd len="sm" w="sm" type="none"/>
-                      <a:tailEnd len="sm" w="sm" type="none"/>
-                    </a:lnB>
-                  </a:tcPr>
-                </a:tc>
-                <a:tc>
-                  <a:txBody>
-                    <a:bodyPr/>
-                    <a:lstStyle/>
-                    <a:p>
-                      <a:pPr indent="0" lvl="0" marL="0" rtl="0" algn="l">
-                        <a:spcBef>
-                          <a:spcPts val="0"/>
-                        </a:spcBef>
-                        <a:spcAft>
-                          <a:spcPts val="0"/>
-                        </a:spcAft>
-                        <a:buNone/>
-                      </a:pPr>
-                      <a:r>
-                        <a:rPr lang="en" sz="1000"/>
-                        <a:t>16% / 13%</a:t>
-                      </a:r>
-                      <a:endParaRPr sz="1000"/>
-                    </a:p>
-                  </a:txBody>
-                  <a:tcPr marT="91425" marB="91425" marR="91425" marL="91425">
-                    <a:lnL cap="flat" cmpd="sng" w="9525">
-                      <a:solidFill>
-                        <a:schemeClr val="dk1"/>
-                      </a:solidFill>
-                      <a:prstDash val="solid"/>
-                      <a:round/>
-                      <a:headEnd len="sm" w="sm" type="none"/>
-                      <a:tailEnd len="sm" w="sm" type="none"/>
-                    </a:lnL>
-                    <a:lnR cap="flat" cmpd="sng" w="9525">
-                      <a:solidFill>
-                        <a:schemeClr val="dk1"/>
-                      </a:solidFill>
-                      <a:prstDash val="solid"/>
-                      <a:round/>
-                      <a:headEnd len="sm" w="sm" type="none"/>
-                      <a:tailEnd len="sm" w="sm" type="none"/>
-                    </a:lnR>
-                    <a:lnT cap="flat" cmpd="sng" w="9525">
-                      <a:solidFill>
-                        <a:schemeClr val="dk1"/>
-                      </a:solidFill>
-                      <a:prstDash val="solid"/>
-                      <a:round/>
-                      <a:headEnd len="sm" w="sm" type="none"/>
-                      <a:tailEnd len="sm" w="sm" type="none"/>
-                    </a:lnT>
-                    <a:lnB cap="flat" cmpd="sng" w="9525">
-                      <a:solidFill>
-                        <a:schemeClr val="dk1"/>
-                      </a:solidFill>
-                      <a:prstDash val="solid"/>
-                      <a:round/>
-                      <a:headEnd len="sm" w="sm" type="none"/>
-                      <a:tailEnd len="sm" w="sm" type="none"/>
-                    </a:lnB>
-                  </a:tcPr>
-                </a:tc>
-              </a:tr>
-              <a:tr h="314250">
-                <a:tc>
-                  <a:txBody>
-                    <a:bodyPr/>
-                    <a:lstStyle/>
-                    <a:p>
-                      <a:pPr indent="0" lvl="0" marL="0" rtl="0" algn="l">
-                        <a:spcBef>
-                          <a:spcPts val="0"/>
-                        </a:spcBef>
-                        <a:spcAft>
-                          <a:spcPts val="0"/>
-                        </a:spcAft>
-                        <a:buNone/>
-                      </a:pPr>
-                      <a:r>
-                        <a:rPr lang="en" sz="1000"/>
-                        <a:t>Ring 64, bidirectional, sparse 13.5%</a:t>
-                      </a:r>
-                      <a:endParaRPr sz="1000"/>
-                    </a:p>
-                  </a:txBody>
-                  <a:tcPr marT="91425" marB="91425" marR="91425" marL="91425">
-                    <a:lnL cap="flat" cmpd="sng" w="9525">
-                      <a:solidFill>
-                        <a:schemeClr val="dk1"/>
-                      </a:solidFill>
-                      <a:prstDash val="solid"/>
-                      <a:round/>
-                      <a:headEnd len="sm" w="sm" type="none"/>
-                      <a:tailEnd len="sm" w="sm" type="none"/>
-                    </a:lnL>
-                    <a:lnR cap="flat" cmpd="sng" w="9525">
-                      <a:solidFill>
-                        <a:schemeClr val="dk1"/>
-                      </a:solidFill>
-                      <a:prstDash val="solid"/>
-                      <a:round/>
-                      <a:headEnd len="sm" w="sm" type="none"/>
-                      <a:tailEnd len="sm" w="sm" type="none"/>
-                    </a:lnR>
-                    <a:lnT cap="flat" cmpd="sng" w="9525">
-                      <a:solidFill>
-                        <a:schemeClr val="dk1"/>
-                      </a:solidFill>
-                      <a:prstDash val="solid"/>
-                      <a:round/>
-                      <a:headEnd len="sm" w="sm" type="none"/>
-                      <a:tailEnd len="sm" w="sm" type="none"/>
-                    </a:lnT>
-                    <a:lnB cap="flat" cmpd="sng" w="9525">
-                      <a:solidFill>
-                        <a:schemeClr val="dk1"/>
-                      </a:solidFill>
-                      <a:prstDash val="solid"/>
-                      <a:round/>
-                      <a:headEnd len="sm" w="sm" type="none"/>
-                      <a:tailEnd len="sm" w="sm" type="none"/>
-                    </a:lnB>
-                  </a:tcPr>
-                </a:tc>
-                <a:tc>
-                  <a:txBody>
-                    <a:bodyPr/>
-                    <a:lstStyle/>
-                    <a:p>
-                      <a:pPr indent="0" lvl="0" marL="0" rtl="0" algn="l">
-                        <a:spcBef>
-                          <a:spcPts val="0"/>
-                        </a:spcBef>
-                        <a:spcAft>
-                          <a:spcPts val="0"/>
-                        </a:spcAft>
-                        <a:buNone/>
-                      </a:pPr>
-                      <a:r>
-                        <a:rPr lang="en" sz="1000"/>
-                        <a:t>1315% / 1329%</a:t>
-                      </a:r>
-                      <a:endParaRPr sz="1000"/>
-                    </a:p>
-                  </a:txBody>
-                  <a:tcPr marT="91425" marB="91425" marR="91425" marL="91425">
-                    <a:lnL cap="flat" cmpd="sng" w="9525">
-                      <a:solidFill>
-                        <a:schemeClr val="dk1"/>
-                      </a:solidFill>
-                      <a:prstDash val="solid"/>
-                      <a:round/>
-                      <a:headEnd len="sm" w="sm" type="none"/>
-                      <a:tailEnd len="sm" w="sm" type="none"/>
-                    </a:lnL>
-                    <a:lnR cap="flat" cmpd="sng" w="9525">
-                      <a:solidFill>
-                        <a:schemeClr val="dk1"/>
-                      </a:solidFill>
-                      <a:prstDash val="solid"/>
-                      <a:round/>
-                      <a:headEnd len="sm" w="sm" type="none"/>
-                      <a:tailEnd len="sm" w="sm" type="none"/>
-                    </a:lnR>
-                    <a:lnT cap="flat" cmpd="sng" w="9525">
-                      <a:solidFill>
-                        <a:schemeClr val="dk1"/>
-                      </a:solidFill>
-                      <a:prstDash val="solid"/>
-                      <a:round/>
-                      <a:headEnd len="sm" w="sm" type="none"/>
-                      <a:tailEnd len="sm" w="sm" type="none"/>
-                    </a:lnT>
-                    <a:lnB cap="flat" cmpd="sng" w="9525">
-                      <a:solidFill>
-                        <a:schemeClr val="dk1"/>
-                      </a:solidFill>
-                      <a:prstDash val="solid"/>
-                      <a:round/>
-                      <a:headEnd len="sm" w="sm" type="none"/>
-                      <a:tailEnd len="sm" w="sm" type="none"/>
-                    </a:lnB>
-                  </a:tcPr>
-                </a:tc>
-                <a:tc>
-                  <a:txBody>
-                    <a:bodyPr/>
-                    <a:lstStyle/>
-                    <a:p>
-                      <a:pPr indent="0" lvl="0" marL="0" rtl="0" algn="l">
-                        <a:spcBef>
-                          <a:spcPts val="0"/>
-                        </a:spcBef>
-                        <a:spcAft>
-                          <a:spcPts val="0"/>
-                        </a:spcAft>
-                        <a:buNone/>
-                      </a:pPr>
-                      <a:r>
-                        <a:rPr lang="en" sz="1000"/>
-                        <a:t>833% / 822%</a:t>
-                      </a:r>
-                      <a:endParaRPr sz="1000"/>
-                    </a:p>
-                  </a:txBody>
-                  <a:tcPr marT="91425" marB="91425" marR="91425" marL="91425">
-                    <a:lnL cap="flat" cmpd="sng" w="9525">
-                      <a:solidFill>
-                        <a:schemeClr val="dk1"/>
-                      </a:solidFill>
-                      <a:prstDash val="solid"/>
-                      <a:round/>
-                      <a:headEnd len="sm" w="sm" type="none"/>
-                      <a:tailEnd len="sm" w="sm" type="none"/>
-                    </a:lnL>
-                    <a:lnR cap="flat" cmpd="sng" w="9525">
-                      <a:solidFill>
-                        <a:schemeClr val="dk1"/>
-                      </a:solidFill>
-                      <a:prstDash val="solid"/>
-                      <a:round/>
-                      <a:headEnd len="sm" w="sm" type="none"/>
-                      <a:tailEnd len="sm" w="sm" type="none"/>
-                    </a:lnR>
-                    <a:lnT cap="flat" cmpd="sng" w="9525">
-                      <a:solidFill>
-                        <a:schemeClr val="dk1"/>
-                      </a:solidFill>
-                      <a:prstDash val="solid"/>
-                      <a:round/>
-                      <a:headEnd len="sm" w="sm" type="none"/>
-                      <a:tailEnd len="sm" w="sm" type="none"/>
-                    </a:lnT>
-                    <a:lnB cap="flat" cmpd="sng" w="9525">
-                      <a:solidFill>
-                        <a:schemeClr val="dk1"/>
-                      </a:solidFill>
-                      <a:prstDash val="solid"/>
-                      <a:round/>
-                      <a:headEnd len="sm" w="sm" type="none"/>
-                      <a:tailEnd len="sm" w="sm" type="none"/>
-                    </a:lnB>
-                  </a:tcPr>
-                </a:tc>
-                <a:tc>
-                  <a:txBody>
-                    <a:bodyPr/>
-                    <a:lstStyle/>
-                    <a:p>
-                      <a:pPr indent="0" lvl="0" marL="0" rtl="0" algn="l">
-                        <a:spcBef>
-                          <a:spcPts val="0"/>
-                        </a:spcBef>
-                        <a:spcAft>
-                          <a:spcPts val="0"/>
-                        </a:spcAft>
-                        <a:buNone/>
-                      </a:pPr>
-                      <a:r>
-                        <a:rPr lang="en" sz="1000"/>
-                        <a:t>27% / 25%</a:t>
-                      </a:r>
-                      <a:endParaRPr sz="1000"/>
-                    </a:p>
-                  </a:txBody>
-                  <a:tcPr marT="91425" marB="91425" marR="91425" marL="91425">
-                    <a:lnL cap="flat" cmpd="sng" w="9525">
-                      <a:solidFill>
-                        <a:schemeClr val="dk1"/>
-                      </a:solidFill>
-                      <a:prstDash val="solid"/>
-                      <a:round/>
-                      <a:headEnd len="sm" w="sm" type="none"/>
-                      <a:tailEnd len="sm" w="sm" type="none"/>
-                    </a:lnL>
-                    <a:lnR cap="flat" cmpd="sng" w="9525">
-                      <a:solidFill>
-                        <a:schemeClr val="dk1"/>
-                      </a:solidFill>
-                      <a:prstDash val="solid"/>
-                      <a:round/>
-                      <a:headEnd len="sm" w="sm" type="none"/>
-                      <a:tailEnd len="sm" w="sm" type="none"/>
-                    </a:lnR>
-                    <a:lnT cap="flat" cmpd="sng" w="9525">
-                      <a:solidFill>
-                        <a:schemeClr val="dk1"/>
-                      </a:solidFill>
-                      <a:prstDash val="solid"/>
-                      <a:round/>
-                      <a:headEnd len="sm" w="sm" type="none"/>
-                      <a:tailEnd len="sm" w="sm" type="none"/>
-                    </a:lnT>
-                    <a:lnB cap="flat" cmpd="sng" w="9525">
-                      <a:solidFill>
-                        <a:schemeClr val="dk1"/>
-                      </a:solidFill>
-                      <a:prstDash val="solid"/>
-                      <a:round/>
-                      <a:headEnd len="sm" w="sm" type="none"/>
-                      <a:tailEnd len="sm" w="sm" type="none"/>
-                    </a:lnB>
-                  </a:tcPr>
-                </a:tc>
-                <a:tc>
-                  <a:txBody>
-                    <a:bodyPr/>
-                    <a:lstStyle/>
-                    <a:p>
-                      <a:pPr indent="0" lvl="0" marL="0" rtl="0" algn="l">
-                        <a:spcBef>
-                          <a:spcPts val="0"/>
-                        </a:spcBef>
-                        <a:spcAft>
-                          <a:spcPts val="0"/>
-                        </a:spcAft>
-                        <a:buNone/>
-                      </a:pPr>
-                      <a:r>
-                        <a:rPr lang="en" sz="1000"/>
-                        <a:t>18% / 15%</a:t>
-                      </a:r>
-                      <a:endParaRPr sz="1000"/>
-                    </a:p>
-                  </a:txBody>
-                  <a:tcPr marT="91425" marB="91425" marR="91425" marL="91425">
-                    <a:lnL cap="flat" cmpd="sng" w="9525">
-                      <a:solidFill>
-                        <a:schemeClr val="dk1"/>
-                      </a:solidFill>
-                      <a:prstDash val="solid"/>
-                      <a:round/>
-                      <a:headEnd len="sm" w="sm" type="none"/>
-                      <a:tailEnd len="sm" w="sm" type="none"/>
-                    </a:lnL>
-                    <a:lnR cap="flat" cmpd="sng" w="9525">
-                      <a:solidFill>
-                        <a:schemeClr val="dk1"/>
-                      </a:solidFill>
-                      <a:prstDash val="solid"/>
-                      <a:round/>
-                      <a:headEnd len="sm" w="sm" type="none"/>
-                      <a:tailEnd len="sm" w="sm" type="none"/>
-                    </a:lnR>
-                    <a:lnT cap="flat" cmpd="sng" w="9525">
-                      <a:solidFill>
-                        <a:schemeClr val="dk1"/>
-                      </a:solidFill>
-                      <a:prstDash val="solid"/>
-                      <a:round/>
-                      <a:headEnd len="sm" w="sm" type="none"/>
-                      <a:tailEnd len="sm" w="sm" type="none"/>
-                    </a:lnT>
-                    <a:lnB cap="flat" cmpd="sng" w="9525">
-                      <a:solidFill>
-                        <a:schemeClr val="dk1"/>
-                      </a:solidFill>
-                      <a:prstDash val="solid"/>
-                      <a:round/>
-                      <a:headEnd len="sm" w="sm" type="none"/>
-                      <a:tailEnd len="sm" w="sm" type="none"/>
-                    </a:lnB>
-                  </a:tcPr>
-                </a:tc>
-              </a:tr>
-              <a:tr h="314250">
-                <a:tc>
-                  <a:txBody>
-                    <a:bodyPr/>
-                    <a:lstStyle/>
-                    <a:p>
-                      <a:pPr indent="0" lvl="0" marL="0" rtl="0" algn="l">
-                        <a:spcBef>
-                          <a:spcPts val="0"/>
-                        </a:spcBef>
-                        <a:spcAft>
-                          <a:spcPts val="0"/>
-                        </a:spcAft>
-                        <a:buNone/>
-                      </a:pPr>
-                      <a:r>
-                        <a:rPr lang="en" sz="1000"/>
-                        <a:t>Ring 64, causal, sparse 13.5%</a:t>
-                      </a:r>
-                      <a:endParaRPr sz="1000"/>
-                    </a:p>
-                  </a:txBody>
-                  <a:tcPr marT="91425" marB="91425" marR="91425" marL="91425">
-                    <a:lnL cap="flat" cmpd="sng" w="9525">
-                      <a:solidFill>
-                        <a:schemeClr val="dk1"/>
-                      </a:solidFill>
-                      <a:prstDash val="solid"/>
-                      <a:round/>
-                      <a:headEnd len="sm" w="sm" type="none"/>
-                      <a:tailEnd len="sm" w="sm" type="none"/>
-                    </a:lnL>
-                    <a:lnR cap="flat" cmpd="sng" w="9525">
-                      <a:solidFill>
-                        <a:schemeClr val="dk1"/>
-                      </a:solidFill>
-                      <a:prstDash val="solid"/>
-                      <a:round/>
-                      <a:headEnd len="sm" w="sm" type="none"/>
-                      <a:tailEnd len="sm" w="sm" type="none"/>
-                    </a:lnR>
-                    <a:lnT cap="flat" cmpd="sng" w="9525">
-                      <a:solidFill>
-                        <a:schemeClr val="dk1"/>
-                      </a:solidFill>
-                      <a:prstDash val="solid"/>
-                      <a:round/>
-                      <a:headEnd len="sm" w="sm" type="none"/>
-                      <a:tailEnd len="sm" w="sm" type="none"/>
-                    </a:lnT>
-                    <a:lnB cap="flat" cmpd="sng" w="9525">
-                      <a:solidFill>
-                        <a:schemeClr val="dk1"/>
-                      </a:solidFill>
-                      <a:prstDash val="solid"/>
-                      <a:round/>
-                      <a:headEnd len="sm" w="sm" type="none"/>
-                      <a:tailEnd len="sm" w="sm" type="none"/>
-                    </a:lnB>
-                  </a:tcPr>
-                </a:tc>
-                <a:tc>
-                  <a:txBody>
-                    <a:bodyPr/>
-                    <a:lstStyle/>
-                    <a:p>
-                      <a:pPr indent="0" lvl="0" marL="0" rtl="0" algn="l">
-                        <a:spcBef>
-                          <a:spcPts val="0"/>
-                        </a:spcBef>
-                        <a:spcAft>
-                          <a:spcPts val="0"/>
-                        </a:spcAft>
-                        <a:buNone/>
-                      </a:pPr>
-                      <a:r>
-                        <a:rPr lang="en" sz="1000"/>
-                        <a:t>2667% / 2735%</a:t>
-                      </a:r>
-                      <a:endParaRPr sz="1000"/>
-                    </a:p>
-                  </a:txBody>
-                  <a:tcPr marT="91425" marB="91425" marR="91425" marL="91425">
-                    <a:lnL cap="flat" cmpd="sng" w="9525">
-                      <a:solidFill>
-                        <a:schemeClr val="dk1"/>
-                      </a:solidFill>
-                      <a:prstDash val="solid"/>
-                      <a:round/>
-                      <a:headEnd len="sm" w="sm" type="none"/>
-                      <a:tailEnd len="sm" w="sm" type="none"/>
-                    </a:lnL>
-                    <a:lnR cap="flat" cmpd="sng" w="9525">
-                      <a:solidFill>
-                        <a:schemeClr val="dk1"/>
-                      </a:solidFill>
-                      <a:prstDash val="solid"/>
-                      <a:round/>
-                      <a:headEnd len="sm" w="sm" type="none"/>
-                      <a:tailEnd len="sm" w="sm" type="none"/>
-                    </a:lnR>
-                    <a:lnT cap="flat" cmpd="sng" w="9525">
-                      <a:solidFill>
-                        <a:schemeClr val="dk1"/>
-                      </a:solidFill>
-                      <a:prstDash val="solid"/>
-                      <a:round/>
-                      <a:headEnd len="sm" w="sm" type="none"/>
-                      <a:tailEnd len="sm" w="sm" type="none"/>
-                    </a:lnT>
-                    <a:lnB cap="flat" cmpd="sng" w="9525">
-                      <a:solidFill>
-                        <a:schemeClr val="dk1"/>
-                      </a:solidFill>
-                      <a:prstDash val="solid"/>
-                      <a:round/>
-                      <a:headEnd len="sm" w="sm" type="none"/>
-                      <a:tailEnd len="sm" w="sm" type="none"/>
-                    </a:lnB>
-                  </a:tcPr>
-                </a:tc>
-                <a:tc>
-                  <a:txBody>
-                    <a:bodyPr/>
-                    <a:lstStyle/>
-                    <a:p>
-                      <a:pPr indent="0" lvl="0" marL="0" rtl="0" algn="l">
-                        <a:spcBef>
-                          <a:spcPts val="0"/>
-                        </a:spcBef>
-                        <a:spcAft>
-                          <a:spcPts val="0"/>
-                        </a:spcAft>
-                        <a:buNone/>
-                      </a:pPr>
-                      <a:r>
-                        <a:rPr lang="en" sz="1000"/>
-                        <a:t>1703% / 1720%</a:t>
-                      </a:r>
-                      <a:endParaRPr sz="1000"/>
-                    </a:p>
-                  </a:txBody>
-                  <a:tcPr marT="91425" marB="91425" marR="91425" marL="91425">
-                    <a:lnL cap="flat" cmpd="sng" w="9525">
-                      <a:solidFill>
-                        <a:schemeClr val="dk1"/>
-                      </a:solidFill>
-                      <a:prstDash val="solid"/>
-                      <a:round/>
-                      <a:headEnd len="sm" w="sm" type="none"/>
-                      <a:tailEnd len="sm" w="sm" type="none"/>
-                    </a:lnL>
-                    <a:lnR cap="flat" cmpd="sng" w="9525">
-                      <a:solidFill>
-                        <a:schemeClr val="dk1"/>
-                      </a:solidFill>
-                      <a:prstDash val="solid"/>
-                      <a:round/>
-                      <a:headEnd len="sm" w="sm" type="none"/>
-                      <a:tailEnd len="sm" w="sm" type="none"/>
-                    </a:lnR>
-                    <a:lnT cap="flat" cmpd="sng" w="9525">
-                      <a:solidFill>
-                        <a:schemeClr val="dk1"/>
-                      </a:solidFill>
-                      <a:prstDash val="solid"/>
-                      <a:round/>
-                      <a:headEnd len="sm" w="sm" type="none"/>
-                      <a:tailEnd len="sm" w="sm" type="none"/>
-                    </a:lnT>
-                    <a:lnB cap="flat" cmpd="sng" w="9525">
-                      <a:solidFill>
-                        <a:schemeClr val="dk1"/>
-                      </a:solidFill>
-                      <a:prstDash val="solid"/>
-                      <a:round/>
-                      <a:headEnd len="sm" w="sm" type="none"/>
-                      <a:tailEnd len="sm" w="sm" type="none"/>
-                    </a:lnB>
-                  </a:tcPr>
-                </a:tc>
-                <a:tc>
-                  <a:txBody>
-                    <a:bodyPr/>
-                    <a:lstStyle/>
-                    <a:p>
-                      <a:pPr indent="0" lvl="0" marL="0" rtl="0" algn="l">
-                        <a:spcBef>
-                          <a:spcPts val="0"/>
-                        </a:spcBef>
-                        <a:spcAft>
-                          <a:spcPts val="0"/>
-                        </a:spcAft>
-                        <a:buNone/>
-                      </a:pPr>
-                      <a:r>
-                        <a:rPr lang="en" sz="1000" b="1"/>
-                        <a:t>37% / 38%</a:t>
-                      </a:r>
-                      <a:endParaRPr sz="1000"/>
-                    </a:p>
-                  </a:txBody>
-                  <a:tcPr marT="91425" marB="91425" marR="91425" marL="91425">
-                    <a:lnL cap="flat" cmpd="sng" w="9525">
-                      <a:solidFill>
-                        <a:schemeClr val="dk1"/>
-                      </a:solidFill>
-                      <a:prstDash val="solid"/>
-                      <a:round/>
-                      <a:headEnd len="sm" w="sm" type="none"/>
-                      <a:tailEnd len="sm" w="sm" type="none"/>
-                    </a:lnL>
-                    <a:lnR cap="flat" cmpd="sng" w="9525">
-                      <a:solidFill>
-                        <a:schemeClr val="dk1"/>
-                      </a:solidFill>
-                      <a:prstDash val="solid"/>
-                      <a:round/>
-                      <a:headEnd len="sm" w="sm" type="none"/>
-                      <a:tailEnd len="sm" w="sm" type="none"/>
-                    </a:lnR>
-                    <a:lnT cap="flat" cmpd="sng" w="9525">
-                      <a:solidFill>
-                        <a:schemeClr val="dk1"/>
-                      </a:solidFill>
-                      <a:prstDash val="solid"/>
-                      <a:round/>
-                      <a:headEnd len="sm" w="sm" type="none"/>
-                      <a:tailEnd len="sm" w="sm" type="none"/>
-                    </a:lnT>
-                    <a:lnB cap="flat" cmpd="sng" w="9525">
-                      <a:solidFill>
-                        <a:schemeClr val="dk1"/>
-                      </a:solidFill>
-                      <a:prstDash val="solid"/>
-                      <a:round/>
-                      <a:headEnd len="sm" w="sm" type="none"/>
-                      <a:tailEnd len="sm" w="sm" type="none"/>
-                    </a:lnB>
-                  </a:tcPr>
-                </a:tc>
-                <a:tc>
-                  <a:txBody>
-                    <a:bodyPr/>
-                    <a:lstStyle/>
-                    <a:p>
-                      <a:pPr indent="0" lvl="0" marL="0" rtl="0" algn="l">
-                        <a:spcBef>
-                          <a:spcPts val="0"/>
-                        </a:spcBef>
-                        <a:spcAft>
-                          <a:spcPts val="0"/>
-                        </a:spcAft>
-                        <a:buNone/>
-                      </a:pPr>
-                      <a:r>
-                        <a:rPr lang="en" sz="1000" b="1"/>
-                        <a:t>21% / 18%</a:t>
-                      </a:r>
-                      <a:endParaRPr sz="1000"/>
-                    </a:p>
-                  </a:txBody>
-                  <a:tcPr marT="91425" marB="91425" marR="91425" marL="91425">
-                    <a:lnL cap="flat" cmpd="sng" w="9525">
-                      <a:solidFill>
-                        <a:schemeClr val="dk1"/>
-                      </a:solidFill>
-                      <a:prstDash val="solid"/>
-                      <a:round/>
-                      <a:headEnd len="sm" w="sm" type="none"/>
-                      <a:tailEnd len="sm" w="sm" type="none"/>
-                    </a:lnL>
-                    <a:lnR cap="flat" cmpd="sng" w="9525">
-                      <a:solidFill>
-                        <a:schemeClr val="dk1"/>
-                      </a:solidFill>
-                      <a:prstDash val="solid"/>
-                      <a:round/>
-                      <a:headEnd len="sm" w="sm" type="none"/>
-                      <a:tailEnd len="sm" w="sm" type="none"/>
-                    </a:lnR>
-                    <a:lnT cap="flat" cmpd="sng" w="9525">
-                      <a:solidFill>
-                        <a:schemeClr val="dk1"/>
-                      </a:solidFill>
-                      <a:prstDash val="solid"/>
-                      <a:round/>
-                      <a:headEnd len="sm" w="sm" type="none"/>
-                      <a:tailEnd len="sm" w="sm" type="none"/>
-                    </a:lnT>
-                    <a:lnB cap="flat" cmpd="sng" w="9525">
-                      <a:solidFill>
-                        <a:schemeClr val="dk1"/>
-                      </a:solidFill>
-                      <a:prstDash val="solid"/>
-                      <a:round/>
-                      <a:headEnd len="sm" w="sm" type="none"/>
-                      <a:tailEnd len="sm" w="sm" type="none"/>
-                    </a:lnB>
-                  </a:tcPr>
-                </a:tc>
-              </a:tr>
-              <a:tr h="314250">
-                <a:tc>
-                  <a:txBody>
-                    <a:bodyPr/>
-                    <a:lstStyle/>
-                    <a:p>
-                      <a:pPr indent="0" lvl="0" marL="0" rtl="0" algn="l">
-                        <a:spcBef>
-                          <a:spcPts val="0"/>
-                        </a:spcBef>
-                        <a:spcAft>
-                          <a:spcPts val="0"/>
-                        </a:spcAft>
-                        <a:buNone/>
-                      </a:pPr>
-                      <a:r>
-                        <a:rPr lang="en" sz="1000"/>
-                        <a:t>Ulysses 8 x ring 8, causal, sparse</a:t>
-                      </a:r>
-                      <a:endParaRPr sz="1000"/>
-                    </a:p>
-                  </a:txBody>
-                  <a:tcPr marT="91425" marB="91425" marR="91425" marL="91425">
-                    <a:lnL cap="flat" cmpd="sng" w="9525">
-                      <a:solidFill>
-                        <a:schemeClr val="dk1"/>
-                      </a:solidFill>
-                      <a:prstDash val="solid"/>
-                      <a:round/>
-                      <a:headEnd len="sm" w="sm" type="none"/>
-                      <a:tailEnd len="sm" w="sm" type="none"/>
-                    </a:lnL>
-                    <a:lnR cap="flat" cmpd="sng" w="9525">
-                      <a:solidFill>
-                        <a:schemeClr val="dk1"/>
-                      </a:solidFill>
-                      <a:prstDash val="solid"/>
-                      <a:round/>
-                      <a:headEnd len="sm" w="sm" type="none"/>
-                      <a:tailEnd len="sm" w="sm" type="none"/>
-                    </a:lnR>
-                    <a:lnT cap="flat" cmpd="sng" w="9525">
-                      <a:solidFill>
-                        <a:schemeClr val="dk1"/>
-                      </a:solidFill>
-                      <a:prstDash val="solid"/>
-                      <a:round/>
-                      <a:headEnd len="sm" w="sm" type="none"/>
-                      <a:tailEnd len="sm" w="sm" type="none"/>
-                    </a:lnT>
-                    <a:lnB cap="flat" cmpd="sng" w="9525">
-                      <a:solidFill>
-                        <a:schemeClr val="dk1"/>
-                      </a:solidFill>
-                      <a:prstDash val="solid"/>
-                      <a:round/>
-                      <a:headEnd len="sm" w="sm" type="none"/>
-                      <a:tailEnd len="sm" w="sm" type="none"/>
-                    </a:lnB>
-                  </a:tcPr>
-                </a:tc>
-                <a:tc>
-                  <a:txBody>
-                    <a:bodyPr/>
-                    <a:lstStyle/>
-                    <a:p>
-                      <a:pPr indent="0" lvl="0" marL="0" rtl="0" algn="l">
-                        <a:spcBef>
-                          <a:spcPts val="0"/>
-                        </a:spcBef>
-                        <a:spcAft>
-                          <a:spcPts val="0"/>
-                        </a:spcAft>
-                        <a:buNone/>
-                      </a:pPr>
-                      <a:r>
-                        <a:rPr lang="en" sz="1000"/>
-                        <a:t>267% / 257%</a:t>
-                      </a:r>
-                      <a:endParaRPr sz="1000"/>
-                    </a:p>
-                  </a:txBody>
-                  <a:tcPr marT="91425" marB="91425" marR="91425" marL="91425">
-                    <a:lnL cap="flat" cmpd="sng" w="9525">
-                      <a:solidFill>
-                        <a:schemeClr val="dk1"/>
-                      </a:solidFill>
-                      <a:prstDash val="solid"/>
-                      <a:round/>
-                      <a:headEnd len="sm" w="sm" type="none"/>
-                      <a:tailEnd len="sm" w="sm" type="none"/>
-                    </a:lnL>
-                    <a:lnR cap="flat" cmpd="sng" w="9525">
-                      <a:solidFill>
-                        <a:schemeClr val="dk1"/>
-                      </a:solidFill>
-                      <a:prstDash val="solid"/>
-                      <a:round/>
-                      <a:headEnd len="sm" w="sm" type="none"/>
-                      <a:tailEnd len="sm" w="sm" type="none"/>
-                    </a:lnR>
-                    <a:lnT cap="flat" cmpd="sng" w="9525">
-                      <a:solidFill>
-                        <a:schemeClr val="dk1"/>
-                      </a:solidFill>
-                      <a:prstDash val="solid"/>
-                      <a:round/>
-                      <a:headEnd len="sm" w="sm" type="none"/>
-                      <a:tailEnd len="sm" w="sm" type="none"/>
-                    </a:lnT>
-                    <a:lnB cap="flat" cmpd="sng" w="9525">
-                      <a:solidFill>
-                        <a:schemeClr val="dk1"/>
-                      </a:solidFill>
-                      <a:prstDash val="solid"/>
-                      <a:round/>
-                      <a:headEnd len="sm" w="sm" type="none"/>
-                      <a:tailEnd len="sm" w="sm" type="none"/>
-                    </a:lnB>
-                  </a:tcPr>
-                </a:tc>
-                <a:tc>
-                  <a:txBody>
-                    <a:bodyPr/>
-                    <a:lstStyle/>
-                    <a:p>
-                      <a:pPr indent="0" lvl="0" marL="0" rtl="0" algn="l">
-                        <a:spcBef>
-                          <a:spcPts val="0"/>
-                        </a:spcBef>
-                        <a:spcAft>
-                          <a:spcPts val="0"/>
-                        </a:spcAft>
-                        <a:buNone/>
-                      </a:pPr>
-                      <a:r>
-                        <a:rPr lang="en" sz="1000"/>
-                        <a:t>160% / 137%</a:t>
-                      </a:r>
-                      <a:endParaRPr sz="1000"/>
-                    </a:p>
-                  </a:txBody>
-                  <a:tcPr marT="91425" marB="91425" marR="91425" marL="91425">
-                    <a:lnL cap="flat" cmpd="sng" w="9525">
-                      <a:solidFill>
-                        <a:schemeClr val="dk1"/>
-                      </a:solidFill>
-                      <a:prstDash val="solid"/>
-                      <a:round/>
-                      <a:headEnd len="sm" w="sm" type="none"/>
-                      <a:tailEnd len="sm" w="sm" type="none"/>
-                    </a:lnL>
-                    <a:lnR cap="flat" cmpd="sng" w="9525">
-                      <a:solidFill>
-                        <a:schemeClr val="dk1"/>
-                      </a:solidFill>
-                      <a:prstDash val="solid"/>
-                      <a:round/>
-                      <a:headEnd len="sm" w="sm" type="none"/>
-                      <a:tailEnd len="sm" w="sm" type="none"/>
-                    </a:lnR>
-                    <a:lnT cap="flat" cmpd="sng" w="9525">
-                      <a:solidFill>
-                        <a:schemeClr val="dk1"/>
-                      </a:solidFill>
-                      <a:prstDash val="solid"/>
-                      <a:round/>
-                      <a:headEnd len="sm" w="sm" type="none"/>
-                      <a:tailEnd len="sm" w="sm" type="none"/>
-                    </a:lnT>
-                    <a:lnB cap="flat" cmpd="sng" w="9525">
-                      <a:solidFill>
-                        <a:schemeClr val="dk1"/>
-                      </a:solidFill>
-                      <a:prstDash val="solid"/>
-                      <a:round/>
-                      <a:headEnd len="sm" w="sm" type="none"/>
-                      <a:tailEnd len="sm" w="sm" type="none"/>
-                    </a:lnB>
-                  </a:tcPr>
-                </a:tc>
-                <a:tc>
-                  <a:txBody>
-                    <a:bodyPr/>
-                    <a:lstStyle/>
-                    <a:p>
-                      <a:pPr indent="0" lvl="0" marL="0" rtl="0" algn="l">
-                        <a:spcBef>
-                          <a:spcPts val="0"/>
-                        </a:spcBef>
-                        <a:spcAft>
-                          <a:spcPts val="0"/>
-                        </a:spcAft>
-                        <a:buNone/>
-                      </a:pPr>
-                      <a:r>
-                        <a:rPr lang="en" sz="1000"/>
-                        <a:t>20% / 16%</a:t>
-                      </a:r>
-                      <a:endParaRPr sz="1000"/>
-                    </a:p>
-                  </a:txBody>
-                  <a:tcPr marT="91425" marB="91425" marR="91425" marL="91425">
-                    <a:lnL cap="flat" cmpd="sng" w="9525">
-                      <a:solidFill>
-                        <a:schemeClr val="dk1"/>
-                      </a:solidFill>
-                      <a:prstDash val="solid"/>
-                      <a:round/>
-                      <a:headEnd len="sm" w="sm" type="none"/>
-                      <a:tailEnd len="sm" w="sm" type="none"/>
-                    </a:lnL>
-                    <a:lnR cap="flat" cmpd="sng" w="9525">
-                      <a:solidFill>
-                        <a:schemeClr val="dk1"/>
-                      </a:solidFill>
-                      <a:prstDash val="solid"/>
-                      <a:round/>
-                      <a:headEnd len="sm" w="sm" type="none"/>
-                      <a:tailEnd len="sm" w="sm" type="none"/>
-                    </a:lnR>
-                    <a:lnT cap="flat" cmpd="sng" w="9525">
-                      <a:solidFill>
-                        <a:schemeClr val="dk1"/>
-                      </a:solidFill>
-                      <a:prstDash val="solid"/>
-                      <a:round/>
-                      <a:headEnd len="sm" w="sm" type="none"/>
-                      <a:tailEnd len="sm" w="sm" type="none"/>
-                    </a:lnT>
-                    <a:lnB cap="flat" cmpd="sng" w="9525">
-                      <a:solidFill>
-                        <a:schemeClr val="dk1"/>
-                      </a:solidFill>
-                      <a:prstDash val="solid"/>
-                      <a:round/>
-                      <a:headEnd len="sm" w="sm" type="none"/>
-                      <a:tailEnd len="sm" w="sm" type="none"/>
-                    </a:lnB>
-                  </a:tcPr>
-                </a:tc>
-                <a:tc>
-                  <a:txBody>
-                    <a:bodyPr/>
-                    <a:lstStyle/>
-                    <a:p>
-                      <a:pPr indent="0" lvl="0" marL="0" rtl="0" algn="l">
-                        <a:spcBef>
-                          <a:spcPts val="0"/>
-                        </a:spcBef>
-                        <a:spcAft>
-                          <a:spcPts val="0"/>
-                        </a:spcAft>
-                        <a:buNone/>
-                      </a:pPr>
-                      <a:r>
-                        <a:rPr lang="en" sz="1000"/>
-                        <a:t>17% / 13%</a:t>
-                      </a:r>
-                      <a:endParaRPr sz="1000"/>
-                    </a:p>
-                  </a:txBody>
-                  <a:tcPr marT="91425" marB="91425" marR="91425" marL="91425">
-                    <a:lnL cap="flat" cmpd="sng" w="9525">
-                      <a:solidFill>
-                        <a:schemeClr val="dk1"/>
-                      </a:solidFill>
-                      <a:prstDash val="solid"/>
-                      <a:round/>
-                      <a:headEnd len="sm" w="sm" type="none"/>
-                      <a:tailEnd len="sm" w="sm" type="none"/>
-                    </a:lnL>
-                    <a:lnR cap="flat" cmpd="sng" w="9525">
-                      <a:solidFill>
-                        <a:schemeClr val="dk1"/>
-                      </a:solidFill>
-                      <a:prstDash val="solid"/>
-                      <a:round/>
-                      <a:headEnd len="sm" w="sm" type="none"/>
-                      <a:tailEnd len="sm" w="sm" type="none"/>
-                    </a:lnR>
-                    <a:lnT cap="flat" cmpd="sng" w="9525">
-                      <a:solidFill>
-                        <a:schemeClr val="dk1"/>
-                      </a:solidFill>
-                      <a:prstDash val="solid"/>
-                      <a:round/>
-                      <a:headEnd len="sm" w="sm" type="none"/>
-                      <a:tailEnd len="sm" w="sm" type="none"/>
-                    </a:lnT>
-                    <a:lnB cap="flat" cmpd="sng" w="9525">
-                      <a:solidFill>
-                        <a:schemeClr val="dk1"/>
-                      </a:solidFill>
-                      <a:prstDash val="solid"/>
-                      <a:round/>
-                      <a:headEnd len="sm" w="sm" type="none"/>
-                      <a:tailEnd len="sm" w="sm" type="none"/>
-                    </a:lnB>
-                  </a:tcPr>
-                </a:tc>
-              </a:tr>
-            </a:tbl>
-          </a:graphicData>
-        </a:graphic>
-      </p:graphicFrame>
-      <p:sp>
-        <p:nvSpPr>
-          <p:cNvPr id="81" name="Next week"/>
+          <p:cNvPr id="82" name="Next week"/>
           <p:cNvSpPr txBox="1"/>
           <p:nvPr/>
         </p:nvSpPr>
         <p:spPr>
           <a:xfrm>
-            <a:off x="310896" y="4251960"/>
-            <a:ext cx="8522208" cy="594360"/>
+            <a:off x="310896" y="4572000"/>
+            <a:ext cx="8522208" cy="365760"/>
           </a:xfrm>
           <a:prstGeom prst="rect">
             <a:avLst/>
@@ -12316,37 +11458,9 @@
                   <a:schemeClr val="dk1"/>
                 </a:solidFill>
               </a:rPr>
-              <a:t> with a ring / sharded KV cache (PAN shapes)</a:t>
+              <a:t> with a sharded full-history KV cache + sparse selection (LingBot / PAN shapes)</a:t>
             </a:r>
             <a:endParaRPr sz="1100">
-              <a:solidFill>
-                <a:schemeClr val="dk1"/>
-              </a:solidFill>
-            </a:endParaRPr>
-          </a:p>
-          <a:p>
-            <a:pPr indent="-298450" lvl="1" marL="914400" rtl="0" algn="l">
-              <a:spcBef>
-                <a:spcPts val="0"/>
-              </a:spcBef>
-              <a:spcAft>
-                <a:spcPts val="0"/>
-              </a:spcAft>
-              <a:buClr>
-                <a:schemeClr val="dk1"/>
-              </a:buClr>
-              <a:buSzPts val="1100"/>
-              <a:buChar char="○"/>
-            </a:pPr>
-            <a:r>
-              <a:rPr lang="en" sz="1100">
-                <a:solidFill>
-                  <a:schemeClr val="dk1"/>
-                </a:solidFill>
-              </a:rPr>
-              <a:t>Above: full-sequence passes (diffusion or training step); 13.5% sparsity from the PAN trace</a:t>
-            </a:r>
-            <a:endParaRPr b="1" sz="1100">
               <a:solidFill>
                 <a:schemeClr val="dk1"/>
               </a:solidFill>

</xml_diff>